<commit_message>
Perbarui data sampai 30 Sep 2026 dan simpan hanya 6 variabel yang dipakai
Data Apr-Sep 2026 diambil dari Yahoo Finance (cocok persis dengan data lama untuk
5 variabel; emas disambung pada 28 Mei 2026). Kolom CPI, BI_rate, US_rate dibuang.
Notebook, README, dan presentasi diperbarui sesuai hasil baru.

Co-Authored-By: Claude Opus 5.5 <noreply@anthropic.com>
</commit_message>
<xml_diff>
--- a/presentation/Presentasi_Ilmuwan_Data_Syamsuddin_Wisnubroto.pptx
+++ b/presentation/Presentasi_Ilmuwan_Data_Syamsuddin_Wisnubroto.pptx
@@ -3767,7 +3767,7 @@
                 </a:solidFill>
                 <a:latin typeface="Calibri"/>
               </a:rPr>
-              <a:t>0,594</a:t>
+              <a:t>0,595</a:t>
             </a:r>
             <a:r>
               <a:rPr sz="1600" b="0">
@@ -3835,7 +3835,7 @@
                 </a:solidFill>
                 <a:latin typeface="Calibri"/>
               </a:rPr>
-              <a:t>aturan sederhana "ikuti S&amp;P 500" sedikit lebih tinggi pada data latih.</a:t>
+              <a:t>aturan sederhana "ikuti S&amp;P 500" setara dengan model terbaik pada data latih.</a:t>
             </a:r>
           </a:p>
         </p:txBody>
@@ -4295,7 +4295,7 @@
                           </a:solidFill>
                           <a:latin typeface="Calibri"/>
                         </a:rPr>
-                        <a:t>0,564</a:t>
+                        <a:t>0,543</a:t>
                       </a:r>
                     </a:p>
                   </a:txBody>
@@ -4317,7 +4317,7 @@
                           </a:solidFill>
                           <a:latin typeface="Calibri"/>
                         </a:rPr>
-                        <a:t>0,555</a:t>
+                        <a:t>0,535</a:t>
                       </a:r>
                     </a:p>
                   </a:txBody>
@@ -4339,7 +4339,7 @@
                           </a:solidFill>
                           <a:latin typeface="Calibri"/>
                         </a:rPr>
-                        <a:t>0,581</a:t>
+                        <a:t>0,577</a:t>
                       </a:r>
                     </a:p>
                   </a:txBody>
@@ -4385,7 +4385,7 @@
                           </a:solidFill>
                           <a:latin typeface="Calibri"/>
                         </a:rPr>
-                        <a:t>0,551</a:t>
+                        <a:t>0,546</a:t>
                       </a:r>
                     </a:p>
                   </a:txBody>
@@ -4407,7 +4407,7 @@
                           </a:solidFill>
                           <a:latin typeface="Calibri"/>
                         </a:rPr>
-                        <a:t>0,548</a:t>
+                        <a:t>0,543</a:t>
                       </a:r>
                     </a:p>
                   </a:txBody>
@@ -4429,7 +4429,7 @@
                           </a:solidFill>
                           <a:latin typeface="Calibri"/>
                         </a:rPr>
-                        <a:t>0,576</a:t>
+                        <a:t>0,575</a:t>
                       </a:r>
                     </a:p>
                   </a:txBody>
@@ -4475,7 +4475,7 @@
                           </a:solidFill>
                           <a:latin typeface="Calibri"/>
                         </a:rPr>
-                        <a:t>0,528</a:t>
+                        <a:t>0,522</a:t>
                       </a:r>
                     </a:p>
                   </a:txBody>
@@ -4497,7 +4497,7 @@
                           </a:solidFill>
                           <a:latin typeface="Calibri"/>
                         </a:rPr>
-                        <a:t>0,346</a:t>
+                        <a:t>0,343</a:t>
                       </a:r>
                     </a:p>
                   </a:txBody>
@@ -4660,7 +4660,7 @@
                           </a:solidFill>
                           <a:latin typeface="Calibri"/>
                         </a:rPr>
-                        <a:t>0,564</a:t>
+                        <a:t>0,543</a:t>
                       </a:r>
                     </a:p>
                   </a:txBody>
@@ -4678,11 +4678,11 @@
                       <a:r>
                         <a:rPr sz="1400" b="0">
                           <a:solidFill>
-                            <a:srgbClr val="1A9850"/>
-                          </a:solidFill>
-                          <a:latin typeface="Calibri"/>
-                        </a:rPr>
-                        <a:t>Ya</a:t>
+                            <a:srgbClr val="D73027"/>
+                          </a:solidFill>
+                          <a:latin typeface="Calibri"/>
+                        </a:rPr>
+                        <a:t>Tidak</a:t>
                       </a:r>
                     </a:p>
                   </a:txBody>
@@ -4728,7 +4728,7 @@
                           </a:solidFill>
                           <a:latin typeface="Calibri"/>
                         </a:rPr>
-                        <a:t>0,555</a:t>
+                        <a:t>0,535</a:t>
                       </a:r>
                     </a:p>
                   </a:txBody>
@@ -4746,11 +4746,11 @@
                       <a:r>
                         <a:rPr sz="1400" b="0">
                           <a:solidFill>
-                            <a:srgbClr val="1A9850"/>
-                          </a:solidFill>
-                          <a:latin typeface="Calibri"/>
-                        </a:rPr>
-                        <a:t>Ya</a:t>
+                            <a:srgbClr val="D73027"/>
+                          </a:solidFill>
+                          <a:latin typeface="Calibri"/>
+                        </a:rPr>
+                        <a:t>Tidak</a:t>
                       </a:r>
                     </a:p>
                   </a:txBody>
@@ -4796,7 +4796,7 @@
                           </a:solidFill>
                           <a:latin typeface="Calibri"/>
                         </a:rPr>
-                        <a:t>0,581</a:t>
+                        <a:t>0,577</a:t>
                       </a:r>
                     </a:p>
                   </a:txBody>
@@ -4814,11 +4814,11 @@
                       <a:r>
                         <a:rPr sz="1400" b="0">
                           <a:solidFill>
-                            <a:srgbClr val="1A9850"/>
-                          </a:solidFill>
-                          <a:latin typeface="Calibri"/>
-                        </a:rPr>
-                        <a:t>Ya</a:t>
+                            <a:srgbClr val="D73027"/>
+                          </a:solidFill>
+                          <a:latin typeface="Calibri"/>
+                        </a:rPr>
+                        <a:t>Tidak</a:t>
                       </a:r>
                     </a:p>
                   </a:txBody>
@@ -4864,7 +4864,7 @@
                           </a:solidFill>
                           <a:latin typeface="Calibri"/>
                         </a:rPr>
-                        <a:t>+0,035</a:t>
+                        <a:t>+0,021</a:t>
                       </a:r>
                     </a:p>
                   </a:txBody>
@@ -4934,7 +4934,7 @@
         <p:spPr>
           <a:xfrm>
             <a:off x="7086600" y="3749039"/>
-            <a:ext cx="4709160" cy="2103120"/>
+            <a:ext cx="4709160" cy="2331720"/>
           </a:xfrm>
           <a:prstGeom prst="rect">
             <a:avLst/>
@@ -4978,7 +4978,7 @@
         <p:spPr>
           <a:xfrm>
             <a:off x="7086600" y="3749039"/>
-            <a:ext cx="64008" cy="2103120"/>
+            <a:ext cx="64008" cy="2331720"/>
           </a:xfrm>
           <a:prstGeom prst="rect">
             <a:avLst/>
@@ -5022,7 +5022,7 @@
         <p:spPr>
           <a:xfrm>
             <a:off x="7315200" y="3858768"/>
-            <a:ext cx="4343400" cy="1920239"/>
+            <a:ext cx="4343400" cy="2148839"/>
           </a:xfrm>
           <a:prstGeom prst="rect">
             <a:avLst/>
@@ -5041,7 +5041,7 @@
               </a:spcAft>
             </a:pPr>
             <a:r>
-              <a:rPr sz="1700" b="1">
+              <a:rPr sz="1600" b="1">
                 <a:solidFill>
                   <a:srgbClr val="1F3A5F"/>
                 </a:solidFill>
@@ -5057,13 +5057,13 @@
               </a:spcAft>
             </a:pPr>
             <a:r>
-              <a:rPr sz="1600" b="0">
+              <a:rPr sz="1500" b="0">
                 <a:solidFill>
                   <a:srgbClr val="222B38"/>
                 </a:solidFill>
                 <a:latin typeface="Calibri"/>
               </a:rPr>
-              <a:t>•  Benar 56,4% dari 795 hari uji</a:t>
+              <a:t>•  Benar 54,3% dari 812 hari uji</a:t>
             </a:r>
           </a:p>
           <a:p>
@@ -5073,13 +5073,13 @@
               </a:spcAft>
             </a:pPr>
             <a:r>
-              <a:rPr sz="1600" b="0">
+              <a:rPr sz="1500" b="0">
                 <a:solidFill>
                   <a:srgbClr val="222B38"/>
                 </a:solidFill>
                 <a:latin typeface="Calibri"/>
               </a:rPr>
-              <a:t>•  Semua target tercapai, tetapi tipis</a:t>
+              <a:t>•  Hanya 1 dari 4 target tercapai</a:t>
             </a:r>
           </a:p>
           <a:p>
@@ -5089,13 +5089,29 @@
               </a:spcAft>
             </a:pPr>
             <a:r>
-              <a:rPr sz="1600" b="0">
+              <a:rPr sz="1500" b="0">
                 <a:solidFill>
                   <a:srgbClr val="222B38"/>
                 </a:solidFill>
                 <a:latin typeface="Calibri"/>
               </a:rPr>
-              <a:t>•  Faktor terpenting: S&amp;P 500 semalam</a:t>
+              <a:t>•  Setara dengan aturan "ikuti S&amp;P 500"</a:t>
+            </a:r>
+          </a:p>
+          <a:p>
+            <a:pPr algn="l">
+              <a:spcAft>
+                <a:spcPts val="800"/>
+              </a:spcAft>
+            </a:pPr>
+            <a:r>
+              <a:rPr sz="1500" b="0">
+                <a:solidFill>
+                  <a:srgbClr val="222B38"/>
+                </a:solidFill>
+                <a:latin typeface="Calibri"/>
+              </a:rPr>
+              <a:t>•  Periode uji penuh gejolak (IHSG −41,5% di 2026)</a:t>
             </a:r>
           </a:p>
         </p:txBody>
@@ -5544,7 +5560,7 @@
                 </a:solidFill>
                 <a:latin typeface="Calibri"/>
               </a:rPr>
-              <a:t>•  Data nyata 16 tahun</a:t>
+              <a:t>•  Data nyata 2010 – Sep 2026</a:t>
             </a:r>
           </a:p>
           <a:p>
@@ -5735,7 +5751,7 @@
                 </a:solidFill>
                 <a:latin typeface="Calibri"/>
               </a:rPr>
-              <a:t>•  Arah pasar harian sulit ditebak</a:t>
+              <a:t>•  Target accuracy, F1, ROC-AUC belum tercapai</a:t>
             </a:r>
           </a:p>
           <a:p>
@@ -5751,7 +5767,7 @@
                 </a:solidFill>
                 <a:latin typeface="Calibri"/>
               </a:rPr>
-              <a:t>•  Kekuatan model terutama dari S&amp;P 500</a:t>
+              <a:t>•  Belum lebih baik dari aturan "ikuti S&amp;P 500"</a:t>
             </a:r>
           </a:p>
           <a:p>
@@ -5767,7 +5783,7 @@
                 </a:solidFill>
                 <a:latin typeface="Calibri"/>
               </a:rPr>
-              <a:t>•  Belum memperhitungkan biaya transaksi</a:t>
+              <a:t>•  Pola lama kurang berlaku saat pasar bergejolak</a:t>
             </a:r>
           </a:p>
         </p:txBody>
@@ -5910,7 +5926,7 @@
                 </a:solidFill>
                 <a:latin typeface="Calibri"/>
               </a:rPr>
-              <a:t>•  Lanjut ke uji coba paralel</a:t>
+              <a:t>•  Belum lanjut ke penggunaan</a:t>
             </a:r>
           </a:p>
           <a:p>
@@ -5926,7 +5942,7 @@
                 </a:solidFill>
                 <a:latin typeface="Calibri"/>
               </a:rPr>
-              <a:t>•  Prediksi dicatat tiap pagi</a:t>
+              <a:t>•  Perbaiki model dulu</a:t>
             </a:r>
           </a:p>
           <a:p>
@@ -5942,7 +5958,7 @@
                 </a:solidFill>
                 <a:latin typeface="Calibri"/>
               </a:rPr>
-              <a:t>•  Belum dipakai untuk keputusan investasi</a:t>
+              <a:t>•  Hasil dilaporkan apa adanya</a:t>
             </a:r>
           </a:p>
         </p:txBody>
@@ -6133,7 +6149,7 @@
                 </a:solidFill>
                 <a:latin typeface="Calibri"/>
               </a:rPr>
-              <a:t>•  Evaluasi ulang dengan data setelah Mei 2026</a:t>
+              <a:t>•  Evaluasi ulang dengan data setelah Sep 2026</a:t>
             </a:r>
           </a:p>
         </p:txBody>
@@ -7277,7 +7293,7 @@
         </p:nvGraphicFramePr>
         <p:xfrm>
           <a:off x="7635240" y="1234440"/>
-          <a:ext cx="4160520" cy="2688336"/>
+          <a:ext cx="4160520" cy="2304288"/>
         </p:xfrm>
         <a:graphic>
           <a:graphicData uri="http://schemas.openxmlformats.org/drawingml/2006/table">
@@ -7565,52 +7581,6 @@
                   </a:tcPr>
                 </a:tc>
               </a:tr>
-              <a:tr h="384048">
-                <a:tc>
-                  <a:txBody>
-                    <a:bodyPr/>
-                    <a:lstStyle/>
-                    <a:p>
-                      <a:r>
-                        <a:rPr sz="1300" b="0">
-                          <a:solidFill>
-                            <a:srgbClr val="222B38"/>
-                          </a:solidFill>
-                          <a:latin typeface="Calibri"/>
-                        </a:rPr>
-                        <a:t>CPI, BI_rate, US_rate</a:t>
-                      </a:r>
-                    </a:p>
-                  </a:txBody>
-                  <a:tcPr anchor="ctr" marL="73152" marR="73152">
-                    <a:solidFill>
-                      <a:srgbClr val="F3F5F9"/>
-                    </a:solidFill>
-                  </a:tcPr>
-                </a:tc>
-                <a:tc>
-                  <a:txBody>
-                    <a:bodyPr/>
-                    <a:lstStyle/>
-                    <a:p>
-                      <a:r>
-                        <a:rPr sz="1300" b="0">
-                          <a:solidFill>
-                            <a:srgbClr val="222B38"/>
-                          </a:solidFill>
-                          <a:latin typeface="Calibri"/>
-                        </a:rPr>
-                        <a:t>Inflasi &amp; suku bunga</a:t>
-                      </a:r>
-                    </a:p>
-                  </a:txBody>
-                  <a:tcPr anchor="ctr" marL="73152" marR="73152">
-                    <a:solidFill>
-                      <a:srgbClr val="F3F5F9"/>
-                    </a:solidFill>
-                  </a:tcPr>
-                </a:tc>
-              </a:tr>
             </a:tbl>
           </a:graphicData>
         </a:graphic>
@@ -7753,7 +7723,7 @@
                 </a:solidFill>
                 <a:latin typeface="Calibri"/>
               </a:rPr>
-              <a:t>Data nyata harian 1 Jan 2010 – 29 Mei 2026: 4.277 baris hari kerja, 9 variabel. IHSG naik pada 54% hari bursa.</a:t>
+              <a:t>Data nyata harian 1 Jan 2010 – 30 Sep 2026 dari Yahoo Finance: 4.365 baris hari kerja, 6 variabel. IHSG naik pada 54% hari bursa.</a:t>
             </a:r>
           </a:p>
         </p:txBody>
@@ -8333,7 +8303,7 @@
                           </a:solidFill>
                           <a:latin typeface="Calibri"/>
                         </a:rPr>
-                        <a:t>Menemukan 5 jenis masalah data</a:t>
+                        <a:t>Menemukan 4 jenis masalah data</a:t>
                       </a:r>
                     </a:p>
                   </a:txBody>
@@ -8469,7 +8439,7 @@
                           </a:solidFill>
                           <a:latin typeface="Calibri"/>
                         </a:rPr>
-                        <a:t>5 langkah perbaikan</a:t>
+                        <a:t>4 langkah perbaikan</a:t>
                       </a:r>
                     </a:p>
                   </a:txBody>
@@ -10545,7 +10515,7 @@
         </p:nvGraphicFramePr>
         <p:xfrm>
           <a:off x="411480" y="3977639"/>
-          <a:ext cx="11384280" cy="2194560"/>
+          <a:ext cx="11384280" cy="1920240"/>
         </p:xfrm>
         <a:graphic>
           <a:graphicData uri="http://schemas.openxmlformats.org/drawingml/2006/table">
@@ -10558,7 +10528,7 @@
                 <a:gridCol w="1828800"/>
                 <a:gridCol w="4069080"/>
               </a:tblGrid>
-              <a:tr h="365760">
+              <a:tr h="384048">
                 <a:tc>
                   <a:txBody>
                     <a:bodyPr/>
@@ -10626,7 +10596,7 @@
                   </a:tcPr>
                 </a:tc>
               </a:tr>
-              <a:tr h="365760">
+              <a:tr h="384048">
                 <a:tc>
                   <a:txBody>
                     <a:bodyPr/>
@@ -10694,7 +10664,7 @@
                   </a:tcPr>
                 </a:tc>
               </a:tr>
-              <a:tr h="365760">
+              <a:tr h="384048">
                 <a:tc>
                   <a:txBody>
                     <a:bodyPr/>
@@ -10762,7 +10732,7 @@
                   </a:tcPr>
                 </a:tc>
               </a:tr>
-              <a:tr h="365760">
+              <a:tr h="384048">
                 <a:tc>
                   <a:txBody>
                     <a:bodyPr/>
@@ -10830,7 +10800,7 @@
                   </a:tcPr>
                 </a:tc>
               </a:tr>
-              <a:tr h="365760">
+              <a:tr h="384048">
                 <a:tc>
                   <a:txBody>
                     <a:bodyPr/>
@@ -10865,7 +10835,7 @@
                           </a:solidFill>
                           <a:latin typeface="Calibri"/>
                         </a:rPr>
-                        <a:t>300 baris</a:t>
+                        <a:t>304 baris</a:t>
                       </a:r>
                     </a:p>
                   </a:txBody>
@@ -10894,74 +10864,6 @@
                   <a:tcPr anchor="ctr" marL="73152" marR="73152">
                     <a:solidFill>
                       <a:srgbClr val="F3F5F9"/>
-                    </a:solidFill>
-                  </a:tcPr>
-                </a:tc>
-              </a:tr>
-              <a:tr h="365760">
-                <a:tc>
-                  <a:txBody>
-                    <a:bodyPr/>
-                    <a:lstStyle/>
-                    <a:p>
-                      <a:r>
-                        <a:rPr sz="1300" b="0">
-                          <a:solidFill>
-                            <a:srgbClr val="222B38"/>
-                          </a:solidFill>
-                          <a:latin typeface="Calibri"/>
-                        </a:rPr>
-                        <a:t>CPI, BI_rate, US_rate jarang berubah</a:t>
-                      </a:r>
-                    </a:p>
-                  </a:txBody>
-                  <a:tcPr anchor="ctr" marL="73152" marR="73152">
-                    <a:solidFill>
-                      <a:srgbClr val="FFFFFF"/>
-                    </a:solidFill>
-                  </a:tcPr>
-                </a:tc>
-                <a:tc>
-                  <a:txBody>
-                    <a:bodyPr/>
-                    <a:lstStyle/>
-                    <a:p>
-                      <a:r>
-                        <a:rPr sz="1300" b="0">
-                          <a:solidFill>
-                            <a:srgbClr val="222B38"/>
-                          </a:solidFill>
-                          <a:latin typeface="Calibri"/>
-                        </a:rPr>
-                        <a:t>3 kolom</a:t>
-                      </a:r>
-                    </a:p>
-                  </a:txBody>
-                  <a:tcPr anchor="ctr" marL="73152" marR="73152">
-                    <a:solidFill>
-                      <a:srgbClr val="FFFFFF"/>
-                    </a:solidFill>
-                  </a:tcPr>
-                </a:tc>
-                <a:tc>
-                  <a:txBody>
-                    <a:bodyPr/>
-                    <a:lstStyle/>
-                    <a:p>
-                      <a:r>
-                        <a:rPr sz="1300" b="0">
-                          <a:solidFill>
-                            <a:srgbClr val="222B38"/>
-                          </a:solidFill>
-                          <a:latin typeface="Calibri"/>
-                        </a:rPr>
-                        <a:t>Tidak dipakai</a:t>
-                      </a:r>
-                    </a:p>
-                  </a:txBody>
-                  <a:tcPr anchor="ctr" marL="73152" marR="73152">
-                    <a:solidFill>
-                      <a:srgbClr val="FFFFFF"/>
                     </a:solidFill>
                   </a:tcPr>
                 </a:tc>
@@ -11286,7 +11188,7 @@
         </p:nvGraphicFramePr>
         <p:xfrm>
           <a:off x="411480" y="1234440"/>
-          <a:ext cx="5577840" cy="2286000"/>
+          <a:ext cx="5577840" cy="1828800"/>
         </p:xfrm>
         <a:graphic>
           <a:graphicData uri="http://schemas.openxmlformats.org/drawingml/2006/table">
@@ -11449,7 +11351,7 @@
                           </a:solidFill>
                           <a:latin typeface="Calibri"/>
                         </a:rPr>
-                        <a:t>CPI</a:t>
+                        <a:t>CPI, BI_rate, US_rate</a:t>
                       </a:r>
                     </a:p>
                   </a:txBody>
@@ -11471,59 +11373,13 @@
                           </a:solidFill>
                           <a:latin typeface="Calibri"/>
                         </a:rPr>
-                        <a:t>Tidak — setahun sekali</a:t>
+                        <a:t>Tidak — jarang berubah</a:t>
                       </a:r>
                     </a:p>
                   </a:txBody>
                   <a:tcPr anchor="ctr" marL="73152" marR="73152">
                     <a:solidFill>
                       <a:srgbClr val="FFFFFF"/>
-                    </a:solidFill>
-                  </a:tcPr>
-                </a:tc>
-              </a:tr>
-              <a:tr h="457200">
-                <a:tc>
-                  <a:txBody>
-                    <a:bodyPr/>
-                    <a:lstStyle/>
-                    <a:p>
-                      <a:r>
-                        <a:rPr sz="1400" b="0">
-                          <a:solidFill>
-                            <a:srgbClr val="222B38"/>
-                          </a:solidFill>
-                          <a:latin typeface="Calibri"/>
-                        </a:rPr>
-                        <a:t>BI_rate, US_rate</a:t>
-                      </a:r>
-                    </a:p>
-                  </a:txBody>
-                  <a:tcPr anchor="ctr" marL="73152" marR="73152">
-                    <a:solidFill>
-                      <a:srgbClr val="F3F5F9"/>
-                    </a:solidFill>
-                  </a:tcPr>
-                </a:tc>
-                <a:tc>
-                  <a:txBody>
-                    <a:bodyPr/>
-                    <a:lstStyle/>
-                    <a:p>
-                      <a:r>
-                        <a:rPr sz="1400" b="0">
-                          <a:solidFill>
-                            <a:srgbClr val="D73027"/>
-                          </a:solidFill>
-                          <a:latin typeface="Calibri"/>
-                        </a:rPr>
-                        <a:t>Tidak — jarang berubah</a:t>
-                      </a:r>
-                    </a:p>
-                  </a:txBody>
-                  <a:tcPr anchor="ctr" marL="73152" marR="73152">
-                    <a:solidFill>
-                      <a:srgbClr val="F3F5F9"/>
                     </a:solidFill>
                   </a:tcPr>
                 </a:tc>
@@ -11615,7 +11471,7 @@
         </p:nvGraphicFramePr>
         <p:xfrm>
           <a:off x="6263640" y="1234440"/>
-          <a:ext cx="5532120" cy="2743200"/>
+          <a:ext cx="5532120" cy="2286000"/>
         </p:xfrm>
         <a:graphic>
           <a:graphicData uri="http://schemas.openxmlformats.org/drawingml/2006/table">
@@ -11708,7 +11564,7 @@
                           </a:solidFill>
                           <a:latin typeface="Calibri"/>
                         </a:rPr>
-                        <a:t>4.277 → 4.276</a:t>
+                        <a:t>4.365 → 4.364</a:t>
                       </a:r>
                     </a:p>
                   </a:txBody>
@@ -11732,7 +11588,7 @@
                           </a:solidFill>
                           <a:latin typeface="Calibri"/>
                         </a:rPr>
-                        <a:t>2. Buang 3 kolom makro</a:t>
+                        <a:t>2. Perbaiki kurs janggal</a:t>
                       </a:r>
                     </a:p>
                   </a:txBody>
@@ -11754,7 +11610,7 @@
                           </a:solidFill>
                           <a:latin typeface="Calibri"/>
                         </a:rPr>
-                        <a:t>6 variabel tersisa</a:t>
+                        <a:t>15 nilai</a:t>
                       </a:r>
                     </a:p>
                   </a:txBody>
@@ -11778,7 +11634,7 @@
                           </a:solidFill>
                           <a:latin typeface="Calibri"/>
                         </a:rPr>
-                        <a:t>3. Perbaiki kurs janggal</a:t>
+                        <a:t>3. Perbaiki minyak negatif</a:t>
                       </a:r>
                     </a:p>
                   </a:txBody>
@@ -11800,7 +11656,7 @@
                           </a:solidFill>
                           <a:latin typeface="Calibri"/>
                         </a:rPr>
-                        <a:t>15 nilai</a:t>
+                        <a:t>1 nilai</a:t>
                       </a:r>
                     </a:p>
                   </a:txBody>
@@ -11824,7 +11680,7 @@
                           </a:solidFill>
                           <a:latin typeface="Calibri"/>
                         </a:rPr>
-                        <a:t>4. Perbaiki minyak negatif</a:t>
+                        <a:t>4. Hapus hari libur BEI</a:t>
                       </a:r>
                     </a:p>
                   </a:txBody>
@@ -11846,59 +11702,13 @@
                           </a:solidFill>
                           <a:latin typeface="Calibri"/>
                         </a:rPr>
-                        <a:t>1 nilai</a:t>
+                        <a:t>4.364 → 4.060</a:t>
                       </a:r>
                     </a:p>
                   </a:txBody>
                   <a:tcPr anchor="ctr" marL="73152" marR="73152">
                     <a:solidFill>
                       <a:srgbClr val="F3F5F9"/>
-                    </a:solidFill>
-                  </a:tcPr>
-                </a:tc>
-              </a:tr>
-              <a:tr h="457200">
-                <a:tc>
-                  <a:txBody>
-                    <a:bodyPr/>
-                    <a:lstStyle/>
-                    <a:p>
-                      <a:r>
-                        <a:rPr sz="1400" b="0">
-                          <a:solidFill>
-                            <a:srgbClr val="222B38"/>
-                          </a:solidFill>
-                          <a:latin typeface="Calibri"/>
-                        </a:rPr>
-                        <a:t>5. Hapus hari libur BEI</a:t>
-                      </a:r>
-                    </a:p>
-                  </a:txBody>
-                  <a:tcPr anchor="ctr" marL="73152" marR="73152">
-                    <a:solidFill>
-                      <a:srgbClr val="FFFFFF"/>
-                    </a:solidFill>
-                  </a:tcPr>
-                </a:tc>
-                <a:tc>
-                  <a:txBody>
-                    <a:bodyPr/>
-                    <a:lstStyle/>
-                    <a:p>
-                      <a:r>
-                        <a:rPr sz="1400" b="0">
-                          <a:solidFill>
-                            <a:srgbClr val="222B38"/>
-                          </a:solidFill>
-                          <a:latin typeface="Calibri"/>
-                        </a:rPr>
-                        <a:t>4.276 → 3.976</a:t>
-                      </a:r>
-                    </a:p>
-                  </a:txBody>
-                  <a:tcPr anchor="ctr" marL="73152" marR="73152">
-                    <a:solidFill>
-                      <a:srgbClr val="FFFFFF"/>
                     </a:solidFill>
                   </a:tcPr>
                 </a:tc>
@@ -11915,7 +11725,7 @@
         </p:nvSpPr>
         <p:spPr>
           <a:xfrm>
-            <a:off x="6263640" y="4206240"/>
+            <a:off x="6263640" y="3749039"/>
             <a:ext cx="5532120" cy="1097280"/>
           </a:xfrm>
           <a:prstGeom prst="rect">
@@ -11959,7 +11769,7 @@
         </p:nvSpPr>
         <p:spPr>
           <a:xfrm>
-            <a:off x="6263640" y="4206240"/>
+            <a:off x="6263640" y="3749039"/>
             <a:ext cx="64008" cy="1097280"/>
           </a:xfrm>
           <a:prstGeom prst="rect">
@@ -12003,7 +11813,7 @@
         </p:nvSpPr>
         <p:spPr>
           <a:xfrm>
-            <a:off x="6492240" y="4315968"/>
+            <a:off x="6492240" y="3858768"/>
             <a:ext cx="5166359" cy="914400"/>
           </a:xfrm>
           <a:prstGeom prst="rect">
@@ -12045,7 +11855,7 @@
                 </a:solidFill>
                 <a:latin typeface="Calibri"/>
               </a:rPr>
-              <a:t>3.976 hari bursa bersih, tanpa data kosong.</a:t>
+              <a:t>4.060 hari bursa bersih, tanpa data kosong.</a:t>
             </a:r>
           </a:p>
         </p:txBody>
@@ -12448,7 +12258,7 @@
                 </a:solidFill>
                 <a:latin typeface="Calibri"/>
               </a:rPr>
-              <a:t>3.179 hari (2010 – Jan 2023).</a:t>
+              <a:t>3.246 hari (2010 – Apr 2023).</a:t>
             </a:r>
           </a:p>
           <a:p>
@@ -12473,7 +12283,7 @@
                 </a:solidFill>
                 <a:latin typeface="Calibri"/>
               </a:rPr>
-              <a:t>795 hari (Jan 2023 – Mei 2026), tidak diacak.</a:t>
+              <a:t>812 hari (Apr 2023 – Sep 2026), tidak diacak.</a:t>
             </a:r>
           </a:p>
         </p:txBody>

</xml_diff>

<commit_message>
Iterasi 2: keluarkan USDIDR, model final Logistic Regression dengan 5 fitur
Kurs USD/IDR dibuang dari data, validasi, pembersihan, dan fitur karena korelasinya
dengan IHSG besok hampir nol dan pengaruhnya paling kecil. Unit 11 mencatat kedua
iterasi beserta catatan bahwa data uji dipakai dua kali.

Co-Authored-By: Claude Opus 5.5 <noreply@anthropic.com>
</commit_message>
<xml_diff>
--- a/presentation/Presentasi_Ilmuwan_Data_Syamsuddin_Wisnubroto.pptx
+++ b/presentation/Presentasi_Ilmuwan_Data_Syamsuddin_Wisnubroto.pptx
@@ -3749,7 +3749,7 @@
                 </a:solidFill>
                 <a:latin typeface="Calibri"/>
               </a:rPr>
-              <a:t>Random Forest </a:t>
+              <a:t>Logistic Regression </a:t>
             </a:r>
             <a:r>
               <a:rPr sz="1600" b="0">
@@ -3767,7 +3767,7 @@
                 </a:solidFill>
                 <a:latin typeface="Calibri"/>
               </a:rPr>
-              <a:t>0,595</a:t>
+              <a:t>0,599</a:t>
             </a:r>
             <a:r>
               <a:rPr sz="1600" b="0">
@@ -3801,7 +3801,7 @@
                 </a:solidFill>
                 <a:latin typeface="Calibri"/>
               </a:rPr>
-              <a:t>Logistic Regression hampir sama baiknya.</a:t>
+              <a:t>Random Forest hampir sama baiknya (0,594).</a:t>
             </a:r>
           </a:p>
           <a:p>
@@ -3835,7 +3835,7 @@
                 </a:solidFill>
                 <a:latin typeface="Calibri"/>
               </a:rPr>
-              <a:t>aturan sederhana "ikuti S&amp;P 500" setara dengan model terbaik pada data latih.</a:t>
+              <a:t>aturan sederhana "ikuti S&amp;P 500" (0,596) hampir sama dengan model terbaik.</a:t>
             </a:r>
           </a:p>
         </p:txBody>
@@ -4273,7 +4273,7 @@
                           </a:solidFill>
                           <a:latin typeface="Calibri"/>
                         </a:rPr>
-                        <a:t>Random Forest</a:t>
+                        <a:t>Logistic Regression</a:t>
                       </a:r>
                     </a:p>
                   </a:txBody>
@@ -4295,7 +4295,7 @@
                           </a:solidFill>
                           <a:latin typeface="Calibri"/>
                         </a:rPr>
-                        <a:t>0,543</a:t>
+                        <a:t>0,558</a:t>
                       </a:r>
                     </a:p>
                   </a:txBody>
@@ -4317,7 +4317,7 @@
                           </a:solidFill>
                           <a:latin typeface="Calibri"/>
                         </a:rPr>
-                        <a:t>0,535</a:t>
+                        <a:t>0,554</a:t>
                       </a:r>
                     </a:p>
                   </a:txBody>
@@ -4339,7 +4339,7 @@
                           </a:solidFill>
                           <a:latin typeface="Calibri"/>
                         </a:rPr>
-                        <a:t>0,577</a:t>
+                        <a:t>0,583</a:t>
                       </a:r>
                     </a:p>
                   </a:txBody>
@@ -4660,7 +4660,7 @@
                           </a:solidFill>
                           <a:latin typeface="Calibri"/>
                         </a:rPr>
-                        <a:t>0,543</a:t>
+                        <a:t>0,558</a:t>
                       </a:r>
                     </a:p>
                   </a:txBody>
@@ -4678,11 +4678,11 @@
                       <a:r>
                         <a:rPr sz="1400" b="0">
                           <a:solidFill>
-                            <a:srgbClr val="D73027"/>
-                          </a:solidFill>
-                          <a:latin typeface="Calibri"/>
-                        </a:rPr>
-                        <a:t>Tidak</a:t>
+                            <a:srgbClr val="1A9850"/>
+                          </a:solidFill>
+                          <a:latin typeface="Calibri"/>
+                        </a:rPr>
+                        <a:t>Ya</a:t>
                       </a:r>
                     </a:p>
                   </a:txBody>
@@ -4728,7 +4728,7 @@
                           </a:solidFill>
                           <a:latin typeface="Calibri"/>
                         </a:rPr>
-                        <a:t>0,535</a:t>
+                        <a:t>0,554</a:t>
                       </a:r>
                     </a:p>
                   </a:txBody>
@@ -4746,11 +4746,11 @@
                       <a:r>
                         <a:rPr sz="1400" b="0">
                           <a:solidFill>
-                            <a:srgbClr val="D73027"/>
-                          </a:solidFill>
-                          <a:latin typeface="Calibri"/>
-                        </a:rPr>
-                        <a:t>Tidak</a:t>
+                            <a:srgbClr val="1A9850"/>
+                          </a:solidFill>
+                          <a:latin typeface="Calibri"/>
+                        </a:rPr>
+                        <a:t>Ya</a:t>
                       </a:r>
                     </a:p>
                   </a:txBody>
@@ -4796,7 +4796,7 @@
                           </a:solidFill>
                           <a:latin typeface="Calibri"/>
                         </a:rPr>
-                        <a:t>0,577</a:t>
+                        <a:t>0,583</a:t>
                       </a:r>
                     </a:p>
                   </a:txBody>
@@ -4814,11 +4814,11 @@
                       <a:r>
                         <a:rPr sz="1400" b="0">
                           <a:solidFill>
-                            <a:srgbClr val="D73027"/>
-                          </a:solidFill>
-                          <a:latin typeface="Calibri"/>
-                        </a:rPr>
-                        <a:t>Tidak</a:t>
+                            <a:srgbClr val="1A9850"/>
+                          </a:solidFill>
+                          <a:latin typeface="Calibri"/>
+                        </a:rPr>
+                        <a:t>Ya</a:t>
                       </a:r>
                     </a:p>
                   </a:txBody>
@@ -4864,7 +4864,7 @@
                           </a:solidFill>
                           <a:latin typeface="Calibri"/>
                         </a:rPr>
-                        <a:t>+0,021</a:t>
+                        <a:t>+0,036</a:t>
                       </a:r>
                     </a:p>
                   </a:txBody>
@@ -4917,8 +4917,8 @@
         </p:blipFill>
         <p:spPr>
           <a:xfrm>
-            <a:off x="7132685" y="1188720"/>
-            <a:ext cx="4616988" cy="2377440"/>
+            <a:off x="7135063" y="1188720"/>
+            <a:ext cx="4612233" cy="2377440"/>
           </a:xfrm>
           <a:prstGeom prst="rect">
             <a:avLst/>
@@ -5063,7 +5063,7 @@
                 </a:solidFill>
                 <a:latin typeface="Calibri"/>
               </a:rPr>
-              <a:t>•  Benar 54,3% dari 812 hari uji</a:t>
+              <a:t>•  Benar 55,8% dari 812 hari uji</a:t>
             </a:r>
           </a:p>
           <a:p>
@@ -5079,7 +5079,7 @@
                 </a:solidFill>
                 <a:latin typeface="Calibri"/>
               </a:rPr>
-              <a:t>•  Hanya 1 dari 4 target tercapai</a:t>
+              <a:t>•  4 dari 4 target tercapai, tetapi tipis</a:t>
             </a:r>
           </a:p>
           <a:p>
@@ -5095,7 +5095,7 @@
                 </a:solidFill>
                 <a:latin typeface="Calibri"/>
               </a:rPr>
-              <a:t>•  Setara dengan aturan "ikuti S&amp;P 500"</a:t>
+              <a:t>•  Iterasi ke-2: 1 variabel lemah dibuang</a:t>
             </a:r>
           </a:p>
           <a:p>
@@ -5111,7 +5111,7 @@
                 </a:solidFill>
                 <a:latin typeface="Calibri"/>
               </a:rPr>
-              <a:t>•  Periode uji penuh gejolak (IHSG −41,5% di 2026)</a:t>
+              <a:t>•  Data uji dipakai 2× → perlu konfirmasi data baru</a:t>
             </a:r>
           </a:p>
         </p:txBody>
@@ -5751,7 +5751,7 @@
                 </a:solidFill>
                 <a:latin typeface="Calibri"/>
               </a:rPr>
-              <a:t>•  Target accuracy, F1, ROC-AUC belum tercapai</a:t>
+              <a:t>•  Selisih terhadap target tipis</a:t>
             </a:r>
           </a:p>
           <a:p>
@@ -5767,7 +5767,7 @@
                 </a:solidFill>
                 <a:latin typeface="Calibri"/>
               </a:rPr>
-              <a:t>•  Belum lebih baik dari aturan "ikuti S&amp;P 500"</a:t>
+              <a:t>•  Hanya sedikit lebih baik dari "ikuti S&amp;P 500"</a:t>
             </a:r>
           </a:p>
           <a:p>
@@ -5783,7 +5783,7 @@
                 </a:solidFill>
                 <a:latin typeface="Calibri"/>
               </a:rPr>
-              <a:t>•  Pola lama kurang berlaku saat pasar bergejolak</a:t>
+              <a:t>•  Data uji dipakai dua kali (2 iterasi)</a:t>
             </a:r>
           </a:p>
         </p:txBody>
@@ -5926,7 +5926,7 @@
                 </a:solidFill>
                 <a:latin typeface="Calibri"/>
               </a:rPr>
-              <a:t>•  Belum lanjut ke penggunaan</a:t>
+              <a:t>•  Lanjut ke uji coba paralel</a:t>
             </a:r>
           </a:p>
           <a:p>
@@ -5942,7 +5942,7 @@
                 </a:solidFill>
                 <a:latin typeface="Calibri"/>
               </a:rPr>
-              <a:t>•  Perbaiki model dulu</a:t>
+              <a:t>•  Konfirmasi dengan data setelah Sep 2026</a:t>
             </a:r>
           </a:p>
           <a:p>
@@ -5958,7 +5958,7 @@
                 </a:solidFill>
                 <a:latin typeface="Calibri"/>
               </a:rPr>
-              <a:t>•  Hasil dilaporkan apa adanya</a:t>
+              <a:t>•  Belum untuk keputusan investasi</a:t>
             </a:r>
           </a:p>
         </p:txBody>
@@ -6659,7 +6659,7 @@
                 </a:solidFill>
                 <a:latin typeface="Calibri"/>
               </a:rPr>
-              <a:t>IHSG dipengaruhi pasar global: saham Amerika, harga minyak, emas, dan kurs rupiah.</a:t>
+              <a:t>IHSG dipengaruhi pasar global: saham Amerika, indeks ketakutan (VIX), harga minyak, dan emas.</a:t>
             </a:r>
           </a:p>
           <a:p>
@@ -7293,7 +7293,7 @@
         </p:nvGraphicFramePr>
         <p:xfrm>
           <a:off x="7635240" y="1234440"/>
-          <a:ext cx="4160520" cy="2304288"/>
+          <a:ext cx="4160520" cy="1920240"/>
         </p:xfrm>
         <a:graphic>
           <a:graphicData uri="http://schemas.openxmlformats.org/drawingml/2006/table">
@@ -7535,52 +7535,6 @@
                   </a:tcPr>
                 </a:tc>
               </a:tr>
-              <a:tr h="384048">
-                <a:tc>
-                  <a:txBody>
-                    <a:bodyPr/>
-                    <a:lstStyle/>
-                    <a:p>
-                      <a:r>
-                        <a:rPr sz="1300" b="0">
-                          <a:solidFill>
-                            <a:srgbClr val="222B38"/>
-                          </a:solidFill>
-                          <a:latin typeface="Calibri"/>
-                        </a:rPr>
-                        <a:t>USDIDR</a:t>
-                      </a:r>
-                    </a:p>
-                  </a:txBody>
-                  <a:tcPr anchor="ctr" marL="73152" marR="73152">
-                    <a:solidFill>
-                      <a:srgbClr val="FFFFFF"/>
-                    </a:solidFill>
-                  </a:tcPr>
-                </a:tc>
-                <a:tc>
-                  <a:txBody>
-                    <a:bodyPr/>
-                    <a:lstStyle/>
-                    <a:p>
-                      <a:r>
-                        <a:rPr sz="1300" b="0">
-                          <a:solidFill>
-                            <a:srgbClr val="222B38"/>
-                          </a:solidFill>
-                          <a:latin typeface="Calibri"/>
-                        </a:rPr>
-                        <a:t>Kurs dolar terhadap rupiah</a:t>
-                      </a:r>
-                    </a:p>
-                  </a:txBody>
-                  <a:tcPr anchor="ctr" marL="73152" marR="73152">
-                    <a:solidFill>
-                      <a:srgbClr val="FFFFFF"/>
-                    </a:solidFill>
-                  </a:tcPr>
-                </a:tc>
-              </a:tr>
             </a:tbl>
           </a:graphicData>
         </a:graphic>
@@ -7723,7 +7677,7 @@
                 </a:solidFill>
                 <a:latin typeface="Calibri"/>
               </a:rPr>
-              <a:t>Data nyata harian 1 Jan 2010 – 30 Sep 2026 dari Yahoo Finance: 4.365 baris hari kerja, 6 variabel. IHSG naik pada 54% hari bursa.</a:t>
+              <a:t>Data nyata harian 1 Jan 2010 – 30 Sep 2026 dari Yahoo Finance: 4.365 baris hari kerja, 5 variabel. IHSG naik pada 54% hari bursa.</a:t>
             </a:r>
           </a:p>
         </p:txBody>
@@ -8303,7 +8257,7 @@
                           </a:solidFill>
                           <a:latin typeface="Calibri"/>
                         </a:rPr>
-                        <a:t>Menemukan 4 jenis masalah data</a:t>
+                        <a:t>Menemukan 3 jenis masalah data</a:t>
                       </a:r>
                     </a:p>
                   </a:txBody>
@@ -8371,7 +8325,7 @@
                           </a:solidFill>
                           <a:latin typeface="Calibri"/>
                         </a:rPr>
-                        <a:t>Memilih 6 variabel dan target</a:t>
+                        <a:t>Memilih 5 variabel dan target</a:t>
                       </a:r>
                     </a:p>
                   </a:txBody>
@@ -8439,7 +8393,7 @@
                           </a:solidFill>
                           <a:latin typeface="Calibri"/>
                         </a:rPr>
-                        <a:t>4 langkah perbaikan</a:t>
+                        <a:t>3 langkah perbaikan</a:t>
                       </a:r>
                     </a:p>
                   </a:txBody>
@@ -8507,7 +8461,7 @@
                           </a:solidFill>
                           <a:latin typeface="Calibri"/>
                         </a:rPr>
-                        <a:t>6 fitur, data latih 80% &amp; uji 20%</a:t>
+                        <a:t>5 fitur, data latih 80% &amp; uji 20%</a:t>
                       </a:r>
                     </a:p>
                   </a:txBody>
@@ -10051,8 +10005,8 @@
         </p:blipFill>
         <p:spPr>
           <a:xfrm>
-            <a:off x="411480" y="1229716"/>
-            <a:ext cx="6766560" cy="3758487"/>
+            <a:off x="411480" y="1202611"/>
+            <a:ext cx="6766560" cy="3812696"/>
           </a:xfrm>
           <a:prstGeom prst="rect">
             <a:avLst/>
@@ -10483,7 +10437,7 @@
       </p:sp>
       <p:pic>
         <p:nvPicPr>
-          <p:cNvPr id="9" name="Picture 8" descr="04_kurs_janggal.png"/>
+          <p:cNvPr id="9" name="Picture 8" descr="04_minyak_negatif.png"/>
           <p:cNvPicPr>
             <a:picLocks noChangeAspect="1"/>
           </p:cNvPicPr>
@@ -10497,8 +10451,8 @@
         </p:blipFill>
         <p:spPr>
           <a:xfrm>
-            <a:off x="2527545" y="1188720"/>
-            <a:ext cx="7152148" cy="2651760"/>
+            <a:off x="2579820" y="1188720"/>
+            <a:ext cx="7047598" cy="2651760"/>
           </a:xfrm>
           <a:prstGeom prst="rect">
             <a:avLst/>
@@ -10677,7 +10631,7 @@
                           </a:solidFill>
                           <a:latin typeface="Calibri"/>
                         </a:rPr>
-                        <a:t>Kurs USD/IDR janggal (mis. 888,11)</a:t>
+                        <a:t>Tanggal ganda</a:t>
                       </a:r>
                     </a:p>
                   </a:txBody>
@@ -10699,7 +10653,7 @@
                           </a:solidFill>
                           <a:latin typeface="Calibri"/>
                         </a:rPr>
-                        <a:t>15 nilai</a:t>
+                        <a:t>0</a:t>
                       </a:r>
                     </a:p>
                   </a:txBody>
@@ -10721,7 +10675,7 @@
                           </a:solidFill>
                           <a:latin typeface="Calibri"/>
                         </a:rPr>
-                        <a:t>Diganti nilai hari sebelumnya</a:t>
+                        <a:t>–</a:t>
                       </a:r>
                     </a:p>
                   </a:txBody>
@@ -11305,7 +11259,7 @@
                           </a:solidFill>
                           <a:latin typeface="Calibri"/>
                         </a:rPr>
-                        <a:t>OIL, GOLD, USDIDR</a:t>
+                        <a:t>OIL, GOLD</a:t>
                       </a:r>
                     </a:p>
                   </a:txBody>
@@ -11471,7 +11425,7 @@
         </p:nvGraphicFramePr>
         <p:xfrm>
           <a:off x="6263640" y="1234440"/>
-          <a:ext cx="5532120" cy="2286000"/>
+          <a:ext cx="5532120" cy="1828800"/>
         </p:xfrm>
         <a:graphic>
           <a:graphicData uri="http://schemas.openxmlformats.org/drawingml/2006/table">
@@ -11588,7 +11542,7 @@
                           </a:solidFill>
                           <a:latin typeface="Calibri"/>
                         </a:rPr>
-                        <a:t>2. Perbaiki kurs janggal</a:t>
+                        <a:t>2. Perbaiki minyak negatif</a:t>
                       </a:r>
                     </a:p>
                   </a:txBody>
@@ -11610,7 +11564,7 @@
                           </a:solidFill>
                           <a:latin typeface="Calibri"/>
                         </a:rPr>
-                        <a:t>15 nilai</a:t>
+                        <a:t>1 nilai</a:t>
                       </a:r>
                     </a:p>
                   </a:txBody>
@@ -11634,7 +11588,7 @@
                           </a:solidFill>
                           <a:latin typeface="Calibri"/>
                         </a:rPr>
-                        <a:t>3. Perbaiki minyak negatif</a:t>
+                        <a:t>3. Hapus hari libur BEI</a:t>
                       </a:r>
                     </a:p>
                   </a:txBody>
@@ -11656,59 +11610,13 @@
                           </a:solidFill>
                           <a:latin typeface="Calibri"/>
                         </a:rPr>
-                        <a:t>1 nilai</a:t>
+                        <a:t>4.364 → 4.060</a:t>
                       </a:r>
                     </a:p>
                   </a:txBody>
                   <a:tcPr anchor="ctr" marL="73152" marR="73152">
                     <a:solidFill>
                       <a:srgbClr val="FFFFFF"/>
-                    </a:solidFill>
-                  </a:tcPr>
-                </a:tc>
-              </a:tr>
-              <a:tr h="457200">
-                <a:tc>
-                  <a:txBody>
-                    <a:bodyPr/>
-                    <a:lstStyle/>
-                    <a:p>
-                      <a:r>
-                        <a:rPr sz="1400" b="0">
-                          <a:solidFill>
-                            <a:srgbClr val="222B38"/>
-                          </a:solidFill>
-                          <a:latin typeface="Calibri"/>
-                        </a:rPr>
-                        <a:t>4. Hapus hari libur BEI</a:t>
-                      </a:r>
-                    </a:p>
-                  </a:txBody>
-                  <a:tcPr anchor="ctr" marL="73152" marR="73152">
-                    <a:solidFill>
-                      <a:srgbClr val="F3F5F9"/>
-                    </a:solidFill>
-                  </a:tcPr>
-                </a:tc>
-                <a:tc>
-                  <a:txBody>
-                    <a:bodyPr/>
-                    <a:lstStyle/>
-                    <a:p>
-                      <a:r>
-                        <a:rPr sz="1400" b="0">
-                          <a:solidFill>
-                            <a:srgbClr val="222B38"/>
-                          </a:solidFill>
-                          <a:latin typeface="Calibri"/>
-                        </a:rPr>
-                        <a:t>4.364 → 4.060</a:t>
-                      </a:r>
-                    </a:p>
-                  </a:txBody>
-                  <a:tcPr anchor="ctr" marL="73152" marR="73152">
-                    <a:solidFill>
-                      <a:srgbClr val="F3F5F9"/>
                     </a:solidFill>
                   </a:tcPr>
                 </a:tc>
@@ -11725,7 +11633,7 @@
         </p:nvSpPr>
         <p:spPr>
           <a:xfrm>
-            <a:off x="6263640" y="3749039"/>
+            <a:off x="6263640" y="3291840"/>
             <a:ext cx="5532120" cy="1097280"/>
           </a:xfrm>
           <a:prstGeom prst="rect">
@@ -11769,7 +11677,7 @@
         </p:nvSpPr>
         <p:spPr>
           <a:xfrm>
-            <a:off x="6263640" y="3749039"/>
+            <a:off x="6263640" y="3291840"/>
             <a:ext cx="64008" cy="1097280"/>
           </a:xfrm>
           <a:prstGeom prst="rect">
@@ -11813,7 +11721,7 @@
         </p:nvSpPr>
         <p:spPr>
           <a:xfrm>
-            <a:off x="6492240" y="3858768"/>
+            <a:off x="6492240" y="3401568"/>
             <a:ext cx="5166359" cy="914400"/>
           </a:xfrm>
           <a:prstGeom prst="rect">
@@ -12224,7 +12132,7 @@
                 </a:solidFill>
                 <a:latin typeface="Calibri"/>
               </a:rPr>
-              <a:t>6 fitur: </a:t>
+              <a:t>5 fitur: </a:t>
             </a:r>
             <a:r>
               <a:rPr sz="1500" b="0">
@@ -12233,7 +12141,7 @@
                 </a:solidFill>
                 <a:latin typeface="Calibri"/>
               </a:rPr>
-              <a:t>perubahan harian (%) IHSG, S&amp;P 500, VIX, minyak, emas, dan USD/IDR.</a:t>
+              <a:t>perubahan harian (%) IHSG, S&amp;P 500, VIX, minyak, dan emas.</a:t>
             </a:r>
           </a:p>
           <a:p>

</xml_diff>

<commit_message>
Kembalikan kurs USD/IDR ke data dan analisis; model akhir tetap 5 fitur
Data mentah kembali berisi 6 variabel (termasuk USDIDR, kode IDR=X). Kurs dibahas di
Unit 3 (keterangan, korelasi -0,02), Unit 4 (15 nilai janggal, batas 4% dan
keterbatasannya), Unit 6 (diperbaiki dengan nilai hari sebelumnya), dan Unit 7 (fitur).

Pemodelan ditulis sebagai dua iterasi: iterasi 1 dengan kurs (Random Forest, 1 dari 4
target) dan iterasi 2 tanpa kurs (Logistic Regression, 4 dari 4 target, model akhir).
Unit 8-11, README, dan presentasi disesuaikan; pemakaian data uji pada dua iterasi
tetap dicatat sebagai keterbatasan.

Co-Authored-By: Claude Opus 5.5 <noreply@anthropic.com>
</commit_message>
<xml_diff>
--- a/presentation/Presentasi_Ilmuwan_Data_Syamsuddin_Wisnubroto.pptx
+++ b/presentation/Presentasi_Ilmuwan_Data_Syamsuddin_Wisnubroto.pptx
@@ -3741,7 +3741,7 @@
                 </a:solidFill>
                 <a:latin typeface="Calibri"/>
               </a:rPr>
-              <a:t>5 fitur: </a:t>
+              <a:t>6 fitur: </a:t>
             </a:r>
             <a:r>
               <a:rPr sz="1500" b="0">
@@ -3750,7 +3750,7 @@
                 </a:solidFill>
                 <a:latin typeface="Calibri"/>
               </a:rPr>
-              <a:t>perubahan harian (%) IHSG, S&amp;P 500, VIX, minyak, dan emas.</a:t>
+              <a:t>perubahan harian (%) IHSG, S&amp;P 500, VIX, minyak, emas, dan kurs.</a:t>
             </a:r>
           </a:p>
           <a:p>
@@ -4116,7 +4116,7 @@
         <p:spPr>
           <a:xfrm>
             <a:off x="7360920" y="4160520"/>
-            <a:ext cx="4434840" cy="1645920"/>
+            <a:ext cx="4434840" cy="1828800"/>
           </a:xfrm>
           <a:prstGeom prst="rect">
             <a:avLst/>
@@ -4142,6 +4142,31 @@
                 <a:latin typeface="Calibri"/>
               </a:rPr>
               <a:t>Model dibandingkan dengan validasi silang deret waktu (5 bagian) pada data latih.</a:t>
+            </a:r>
+          </a:p>
+          <a:p>
+            <a:pPr algn="l">
+              <a:spcAft>
+                <a:spcPts val="800"/>
+              </a:spcAft>
+            </a:pPr>
+            <a:r>
+              <a:rPr sz="1400" b="1">
+                <a:solidFill>
+                  <a:srgbClr val="5A6778"/>
+                </a:solidFill>
+                <a:latin typeface="Calibri"/>
+              </a:rPr>
+              <a:t>2 iterasi: </a:t>
+            </a:r>
+            <a:r>
+              <a:rPr sz="1400" b="0">
+                <a:solidFill>
+                  <a:srgbClr val="5A6778"/>
+                </a:solidFill>
+                <a:latin typeface="Calibri"/>
+              </a:rPr>
+              <a:t>dengan kurs (6 fitur), lalu tanpa kurs (5 fitur).</a:t>
             </a:r>
           </a:p>
         </p:txBody>
@@ -4468,8 +4493,8 @@
         </p:blipFill>
         <p:spPr>
           <a:xfrm>
-            <a:off x="411480" y="1256607"/>
-            <a:ext cx="6949440" cy="3247505"/>
+            <a:off x="411480" y="1246987"/>
+            <a:ext cx="6949440" cy="3266744"/>
           </a:xfrm>
           <a:prstGeom prst="rect">
             <a:avLst/>
@@ -4485,7 +4510,7 @@
         <p:spPr>
           <a:xfrm>
             <a:off x="7635240" y="1325880"/>
-            <a:ext cx="4160520" cy="4114800"/>
+            <a:ext cx="4160520" cy="4572000"/>
           </a:xfrm>
           <a:prstGeom prst="rect">
             <a:avLst/>
@@ -4519,7 +4544,7 @@
                 </a:solidFill>
                 <a:latin typeface="Calibri"/>
               </a:rPr>
-              <a:t>Logistic Regression </a:t>
+              <a:t>Iterasi 1 (dengan kurs): </a:t>
             </a:r>
             <a:r>
               <a:rPr sz="1600" b="0">
@@ -4528,25 +4553,7 @@
                 </a:solidFill>
                 <a:latin typeface="Calibri"/>
               </a:rPr>
-              <a:t>dipilih (accuracy validasi </a:t>
-            </a:r>
-            <a:r>
-              <a:rPr sz="1600" b="1">
-                <a:solidFill>
-                  <a:srgbClr val="222B38"/>
-                </a:solidFill>
-                <a:latin typeface="Calibri"/>
-              </a:rPr>
-              <a:t>0,599</a:t>
-            </a:r>
-            <a:r>
-              <a:rPr sz="1600" b="0">
-                <a:solidFill>
-                  <a:srgbClr val="222B38"/>
-                </a:solidFill>
-                <a:latin typeface="Calibri"/>
-              </a:rPr>
-              <a:t>).</a:t>
+              <a:t>Random Forest terbaik (0,595).</a:t>
             </a:r>
           </a:p>
           <a:p>
@@ -4565,13 +4572,65 @@
               <a:t>■  </a:t>
             </a:r>
             <a:r>
-              <a:rPr sz="1600" b="0">
+              <a:rPr sz="1600" b="1">
                 <a:solidFill>
                   <a:srgbClr val="222B38"/>
                 </a:solidFill>
                 <a:latin typeface="Calibri"/>
               </a:rPr>
-              <a:t>Random Forest hampir sama baiknya (0,594).</a:t>
+              <a:t>Iterasi 2 (tanpa kurs): </a:t>
+            </a:r>
+            <a:r>
+              <a:rPr sz="1600" b="0">
+                <a:solidFill>
+                  <a:srgbClr val="222B38"/>
+                </a:solidFill>
+                <a:latin typeface="Calibri"/>
+              </a:rPr>
+              <a:t>Logistic Regression terbaik (</a:t>
+            </a:r>
+            <a:r>
+              <a:rPr sz="1600" b="1">
+                <a:solidFill>
+                  <a:srgbClr val="222B38"/>
+                </a:solidFill>
+                <a:latin typeface="Calibri"/>
+              </a:rPr>
+              <a:t>0,599</a:t>
+            </a:r>
+            <a:r>
+              <a:rPr sz="1600" b="0">
+                <a:solidFill>
+                  <a:srgbClr val="222B38"/>
+                </a:solidFill>
+                <a:latin typeface="Calibri"/>
+              </a:rPr>
+              <a:t>) → model akhir.</a:t>
+            </a:r>
+          </a:p>
+          <a:p>
+            <a:pPr algn="l">
+              <a:spcAft>
+                <a:spcPts val="800"/>
+              </a:spcAft>
+            </a:pPr>
+            <a:r>
+              <a:rPr sz="1000" b="0">
+                <a:solidFill>
+                  <a:srgbClr val="E08214"/>
+                </a:solidFill>
+                <a:latin typeface="Calibri"/>
+              </a:rPr>
+              <a:t>■  </a:t>
+            </a:r>
+            <a:r>
+              <a:rPr sz="1600" b="0">
+                <a:solidFill>
+                  <a:srgbClr val="222B38"/>
+                </a:solidFill>
+                <a:latin typeface="Calibri"/>
+              </a:rPr>
+              <a:t>Tanpa kurs, hasil validasi tidak turun.</a:t>
             </a:r>
           </a:p>
           <a:p>
@@ -4926,7 +4985,7 @@
         </p:nvGraphicFramePr>
         <p:xfrm>
           <a:off x="411480" y="1234440"/>
-          <a:ext cx="6400800" cy="1828800"/>
+          <a:ext cx="6400800" cy="2148840"/>
         </p:xfrm>
         <a:graphic>
           <a:graphicData uri="http://schemas.openxmlformats.org/drawingml/2006/table">
@@ -4935,19 +4994,19 @@
                 <a:tableStyleId>{5C22544A-7EE6-4342-B048-85BDC9FD1C3A}</a:tableStyleId>
               </a:tblPr>
               <a:tblGrid>
-                <a:gridCol w="3108960"/>
-                <a:gridCol w="1097280"/>
-                <a:gridCol w="1097280"/>
-                <a:gridCol w="1097280"/>
+                <a:gridCol w="3520440"/>
+                <a:gridCol w="960120"/>
+                <a:gridCol w="960120"/>
+                <a:gridCol w="960120"/>
               </a:tblGrid>
-              <a:tr h="457200">
-                <a:tc>
-                  <a:txBody>
-                    <a:bodyPr/>
-                    <a:lstStyle/>
-                    <a:p>
-                      <a:r>
-                        <a:rPr sz="1400" b="1">
+              <a:tr h="429768">
+                <a:tc>
+                  <a:txBody>
+                    <a:bodyPr/>
+                    <a:lstStyle/>
+                    <a:p>
+                      <a:r>
+                        <a:rPr sz="1300" b="1">
                           <a:solidFill>
                             <a:srgbClr val="FFFFFF"/>
                           </a:solidFill>
@@ -4969,7 +5028,7 @@
                     <a:lstStyle/>
                     <a:p>
                       <a:r>
-                        <a:rPr sz="1400" b="1">
+                        <a:rPr sz="1300" b="1">
                           <a:solidFill>
                             <a:srgbClr val="FFFFFF"/>
                           </a:solidFill>
@@ -4991,7 +5050,7 @@
                     <a:lstStyle/>
                     <a:p>
                       <a:r>
-                        <a:rPr sz="1400" b="1">
+                        <a:rPr sz="1300" b="1">
                           <a:solidFill>
                             <a:srgbClr val="FFFFFF"/>
                           </a:solidFill>
@@ -5013,7 +5072,7 @@
                     <a:lstStyle/>
                     <a:p>
                       <a:r>
-                        <a:rPr sz="1400" b="1">
+                        <a:rPr sz="1300" b="1">
                           <a:solidFill>
                             <a:srgbClr val="FFFFFF"/>
                           </a:solidFill>
@@ -5030,20 +5089,20 @@
                   </a:tcPr>
                 </a:tc>
               </a:tr>
-              <a:tr h="457200">
-                <a:tc>
-                  <a:txBody>
-                    <a:bodyPr/>
-                    <a:lstStyle/>
-                    <a:p>
-                      <a:r>
-                        <a:rPr sz="1400" b="1">
+              <a:tr h="429768">
+                <a:tc>
+                  <a:txBody>
+                    <a:bodyPr/>
+                    <a:lstStyle/>
+                    <a:p>
+                      <a:r>
+                        <a:rPr sz="1300" b="1">
                           <a:solidFill>
                             <a:srgbClr val="222B38"/>
                           </a:solidFill>
                           <a:latin typeface="Calibri"/>
                         </a:rPr>
-                        <a:t>Logistic Regression</a:t>
+                        <a:t>Iterasi 2: Logistic Regression</a:t>
                       </a:r>
                     </a:p>
                   </a:txBody>
@@ -5059,7 +5118,7 @@
                     <a:lstStyle/>
                     <a:p>
                       <a:r>
-                        <a:rPr sz="1400" b="1">
+                        <a:rPr sz="1300" b="1">
                           <a:solidFill>
                             <a:srgbClr val="222B38"/>
                           </a:solidFill>
@@ -5081,7 +5140,7 @@
                     <a:lstStyle/>
                     <a:p>
                       <a:r>
-                        <a:rPr sz="1400" b="1">
+                        <a:rPr sz="1300" b="1">
                           <a:solidFill>
                             <a:srgbClr val="222B38"/>
                           </a:solidFill>
@@ -5103,7 +5162,7 @@
                     <a:lstStyle/>
                     <a:p>
                       <a:r>
-                        <a:rPr sz="1400" b="1">
+                        <a:rPr sz="1300" b="1">
                           <a:solidFill>
                             <a:srgbClr val="222B38"/>
                           </a:solidFill>
@@ -5120,25 +5179,205 @@
                   </a:tcPr>
                 </a:tc>
               </a:tr>
-              <a:tr h="457200">
-                <a:tc>
-                  <a:txBody>
-                    <a:bodyPr/>
-                    <a:lstStyle/>
-                    <a:p>
-                      <a:r>
-                        <a:rPr sz="1400" b="0">
+              <a:tr h="429768">
+                <a:tc>
+                  <a:txBody>
+                    <a:bodyPr/>
+                    <a:lstStyle/>
+                    <a:p>
+                      <a:r>
+                        <a:rPr sz="1300" b="0">
                           <a:solidFill>
                             <a:srgbClr val="222B38"/>
                           </a:solidFill>
                           <a:latin typeface="Calibri"/>
                         </a:rPr>
+                        <a:t>Iterasi 1: Random Forest</a:t>
+                      </a:r>
+                    </a:p>
+                  </a:txBody>
+                  <a:tcPr anchor="ctr" marL="73152" marR="73152">
+                    <a:solidFill>
+                      <a:srgbClr val="F3F5F9"/>
+                    </a:solidFill>
+                  </a:tcPr>
+                </a:tc>
+                <a:tc>
+                  <a:txBody>
+                    <a:bodyPr/>
+                    <a:lstStyle/>
+                    <a:p>
+                      <a:r>
+                        <a:rPr sz="1300" b="0">
+                          <a:solidFill>
+                            <a:srgbClr val="222B38"/>
+                          </a:solidFill>
+                          <a:latin typeface="Calibri"/>
+                        </a:rPr>
+                        <a:t>0,543</a:t>
+                      </a:r>
+                    </a:p>
+                  </a:txBody>
+                  <a:tcPr anchor="ctr" marL="73152" marR="73152">
+                    <a:solidFill>
+                      <a:srgbClr val="F3F5F9"/>
+                    </a:solidFill>
+                  </a:tcPr>
+                </a:tc>
+                <a:tc>
+                  <a:txBody>
+                    <a:bodyPr/>
+                    <a:lstStyle/>
+                    <a:p>
+                      <a:r>
+                        <a:rPr sz="1300" b="0">
+                          <a:solidFill>
+                            <a:srgbClr val="222B38"/>
+                          </a:solidFill>
+                          <a:latin typeface="Calibri"/>
+                        </a:rPr>
+                        <a:t>0,535</a:t>
+                      </a:r>
+                    </a:p>
+                  </a:txBody>
+                  <a:tcPr anchor="ctr" marL="73152" marR="73152">
+                    <a:solidFill>
+                      <a:srgbClr val="F3F5F9"/>
+                    </a:solidFill>
+                  </a:tcPr>
+                </a:tc>
+                <a:tc>
+                  <a:txBody>
+                    <a:bodyPr/>
+                    <a:lstStyle/>
+                    <a:p>
+                      <a:r>
+                        <a:rPr sz="1300" b="0">
+                          <a:solidFill>
+                            <a:srgbClr val="222B38"/>
+                          </a:solidFill>
+                          <a:latin typeface="Calibri"/>
+                        </a:rPr>
+                        <a:t>0,577</a:t>
+                      </a:r>
+                    </a:p>
+                  </a:txBody>
+                  <a:tcPr anchor="ctr" marL="73152" marR="73152">
+                    <a:solidFill>
+                      <a:srgbClr val="F3F5F9"/>
+                    </a:solidFill>
+                  </a:tcPr>
+                </a:tc>
+              </a:tr>
+              <a:tr h="429768">
+                <a:tc>
+                  <a:txBody>
+                    <a:bodyPr/>
+                    <a:lstStyle/>
+                    <a:p>
+                      <a:r>
+                        <a:rPr sz="1300" b="0">
+                          <a:solidFill>
+                            <a:srgbClr val="222B38"/>
+                          </a:solidFill>
+                          <a:latin typeface="Calibri"/>
+                        </a:rPr>
                         <a:t>Ikuti S&amp;P 500 (baseline)</a:t>
                       </a:r>
                     </a:p>
                   </a:txBody>
                   <a:tcPr anchor="ctr" marL="73152" marR="73152">
                     <a:solidFill>
+                      <a:srgbClr val="FFFFFF"/>
+                    </a:solidFill>
+                  </a:tcPr>
+                </a:tc>
+                <a:tc>
+                  <a:txBody>
+                    <a:bodyPr/>
+                    <a:lstStyle/>
+                    <a:p>
+                      <a:r>
+                        <a:rPr sz="1300" b="0">
+                          <a:solidFill>
+                            <a:srgbClr val="222B38"/>
+                          </a:solidFill>
+                          <a:latin typeface="Calibri"/>
+                        </a:rPr>
+                        <a:t>0,546</a:t>
+                      </a:r>
+                    </a:p>
+                  </a:txBody>
+                  <a:tcPr anchor="ctr" marL="73152" marR="73152">
+                    <a:solidFill>
+                      <a:srgbClr val="FFFFFF"/>
+                    </a:solidFill>
+                  </a:tcPr>
+                </a:tc>
+                <a:tc>
+                  <a:txBody>
+                    <a:bodyPr/>
+                    <a:lstStyle/>
+                    <a:p>
+                      <a:r>
+                        <a:rPr sz="1300" b="0">
+                          <a:solidFill>
+                            <a:srgbClr val="222B38"/>
+                          </a:solidFill>
+                          <a:latin typeface="Calibri"/>
+                        </a:rPr>
+                        <a:t>0,543</a:t>
+                      </a:r>
+                    </a:p>
+                  </a:txBody>
+                  <a:tcPr anchor="ctr" marL="73152" marR="73152">
+                    <a:solidFill>
+                      <a:srgbClr val="FFFFFF"/>
+                    </a:solidFill>
+                  </a:tcPr>
+                </a:tc>
+                <a:tc>
+                  <a:txBody>
+                    <a:bodyPr/>
+                    <a:lstStyle/>
+                    <a:p>
+                      <a:r>
+                        <a:rPr sz="1300" b="0">
+                          <a:solidFill>
+                            <a:srgbClr val="222B38"/>
+                          </a:solidFill>
+                          <a:latin typeface="Calibri"/>
+                        </a:rPr>
+                        <a:t>0,575</a:t>
+                      </a:r>
+                    </a:p>
+                  </a:txBody>
+                  <a:tcPr anchor="ctr" marL="73152" marR="73152">
+                    <a:solidFill>
+                      <a:srgbClr val="FFFFFF"/>
+                    </a:solidFill>
+                  </a:tcPr>
+                </a:tc>
+              </a:tr>
+              <a:tr h="429768">
+                <a:tc>
+                  <a:txBody>
+                    <a:bodyPr/>
+                    <a:lstStyle/>
+                    <a:p>
+                      <a:r>
+                        <a:rPr sz="1300" b="0">
+                          <a:solidFill>
+                            <a:srgbClr val="222B38"/>
+                          </a:solidFill>
+                          <a:latin typeface="Calibri"/>
+                        </a:rPr>
+                        <a:t>Selalu Naik (baseline)</a:t>
+                      </a:r>
+                    </a:p>
+                  </a:txBody>
+                  <a:tcPr anchor="ctr" marL="73152" marR="73152">
+                    <a:solidFill>
                       <a:srgbClr val="F3F5F9"/>
                     </a:solidFill>
                   </a:tcPr>
@@ -5149,13 +5388,13 @@
                     <a:lstStyle/>
                     <a:p>
                       <a:r>
-                        <a:rPr sz="1400" b="0">
+                        <a:rPr sz="1300" b="0">
                           <a:solidFill>
                             <a:srgbClr val="222B38"/>
                           </a:solidFill>
                           <a:latin typeface="Calibri"/>
                         </a:rPr>
-                        <a:t>0,546</a:t>
+                        <a:t>0,522</a:t>
                       </a:r>
                     </a:p>
                   </a:txBody>
@@ -5171,13 +5410,13 @@
                     <a:lstStyle/>
                     <a:p>
                       <a:r>
-                        <a:rPr sz="1400" b="0">
+                        <a:rPr sz="1300" b="0">
                           <a:solidFill>
                             <a:srgbClr val="222B38"/>
                           </a:solidFill>
                           <a:latin typeface="Calibri"/>
                         </a:rPr>
-                        <a:t>0,543</a:t>
+                        <a:t>0,343</a:t>
                       </a:r>
                     </a:p>
                   </a:txBody>
@@ -5193,109 +5432,19 @@
                     <a:lstStyle/>
                     <a:p>
                       <a:r>
-                        <a:rPr sz="1400" b="0">
+                        <a:rPr sz="1300" b="0">
                           <a:solidFill>
                             <a:srgbClr val="222B38"/>
                           </a:solidFill>
                           <a:latin typeface="Calibri"/>
                         </a:rPr>
-                        <a:t>0,575</a:t>
+                        <a:t>0,500</a:t>
                       </a:r>
                     </a:p>
                   </a:txBody>
                   <a:tcPr anchor="ctr" marL="73152" marR="73152">
                     <a:solidFill>
                       <a:srgbClr val="F3F5F9"/>
-                    </a:solidFill>
-                  </a:tcPr>
-                </a:tc>
-              </a:tr>
-              <a:tr h="457200">
-                <a:tc>
-                  <a:txBody>
-                    <a:bodyPr/>
-                    <a:lstStyle/>
-                    <a:p>
-                      <a:r>
-                        <a:rPr sz="1400" b="0">
-                          <a:solidFill>
-                            <a:srgbClr val="222B38"/>
-                          </a:solidFill>
-                          <a:latin typeface="Calibri"/>
-                        </a:rPr>
-                        <a:t>Selalu Naik (baseline)</a:t>
-                      </a:r>
-                    </a:p>
-                  </a:txBody>
-                  <a:tcPr anchor="ctr" marL="73152" marR="73152">
-                    <a:solidFill>
-                      <a:srgbClr val="FFFFFF"/>
-                    </a:solidFill>
-                  </a:tcPr>
-                </a:tc>
-                <a:tc>
-                  <a:txBody>
-                    <a:bodyPr/>
-                    <a:lstStyle/>
-                    <a:p>
-                      <a:r>
-                        <a:rPr sz="1400" b="0">
-                          <a:solidFill>
-                            <a:srgbClr val="222B38"/>
-                          </a:solidFill>
-                          <a:latin typeface="Calibri"/>
-                        </a:rPr>
-                        <a:t>0,522</a:t>
-                      </a:r>
-                    </a:p>
-                  </a:txBody>
-                  <a:tcPr anchor="ctr" marL="73152" marR="73152">
-                    <a:solidFill>
-                      <a:srgbClr val="FFFFFF"/>
-                    </a:solidFill>
-                  </a:tcPr>
-                </a:tc>
-                <a:tc>
-                  <a:txBody>
-                    <a:bodyPr/>
-                    <a:lstStyle/>
-                    <a:p>
-                      <a:r>
-                        <a:rPr sz="1400" b="0">
-                          <a:solidFill>
-                            <a:srgbClr val="222B38"/>
-                          </a:solidFill>
-                          <a:latin typeface="Calibri"/>
-                        </a:rPr>
-                        <a:t>0,343</a:t>
-                      </a:r>
-                    </a:p>
-                  </a:txBody>
-                  <a:tcPr anchor="ctr" marL="73152" marR="73152">
-                    <a:solidFill>
-                      <a:srgbClr val="FFFFFF"/>
-                    </a:solidFill>
-                  </a:tcPr>
-                </a:tc>
-                <a:tc>
-                  <a:txBody>
-                    <a:bodyPr/>
-                    <a:lstStyle/>
-                    <a:p>
-                      <a:r>
-                        <a:rPr sz="1400" b="0">
-                          <a:solidFill>
-                            <a:srgbClr val="222B38"/>
-                          </a:solidFill>
-                          <a:latin typeface="Calibri"/>
-                        </a:rPr>
-                        <a:t>0,500</a:t>
-                      </a:r>
-                    </a:p>
-                  </a:txBody>
-                  <a:tcPr anchor="ctr" marL="73152" marR="73152">
-                    <a:solidFill>
-                      <a:srgbClr val="FFFFFF"/>
                     </a:solidFill>
                   </a:tcPr>
                 </a:tc>
@@ -5313,8 +5462,8 @@
           <p:nvPr/>
         </p:nvGraphicFramePr>
         <p:xfrm>
-          <a:off x="411480" y="3337560"/>
-          <a:ext cx="6400800" cy="2148840"/>
+          <a:off x="411480" y="3657600"/>
+          <a:ext cx="6400800" cy="2057400"/>
         </p:xfrm>
         <a:graphic>
           <a:graphicData uri="http://schemas.openxmlformats.org/drawingml/2006/table">
@@ -5327,14 +5476,14 @@
                 <a:gridCol w="1280160"/>
                 <a:gridCol w="1280160"/>
               </a:tblGrid>
-              <a:tr h="429768">
-                <a:tc>
-                  <a:txBody>
-                    <a:bodyPr/>
-                    <a:lstStyle/>
-                    <a:p>
-                      <a:r>
-                        <a:rPr sz="1400" b="1">
+              <a:tr h="411480">
+                <a:tc>
+                  <a:txBody>
+                    <a:bodyPr/>
+                    <a:lstStyle/>
+                    <a:p>
+                      <a:r>
+                        <a:rPr sz="1300" b="1">
                           <a:solidFill>
                             <a:srgbClr val="FFFFFF"/>
                           </a:solidFill>
@@ -5356,13 +5505,13 @@
                     <a:lstStyle/>
                     <a:p>
                       <a:r>
-                        <a:rPr sz="1400" b="1">
+                        <a:rPr sz="1300" b="1">
                           <a:solidFill>
                             <a:srgbClr val="FFFFFF"/>
                           </a:solidFill>
                           <a:latin typeface="Calibri"/>
                         </a:rPr>
-                        <a:t>Nilai</a:t>
+                        <a:t>Iterasi 1</a:t>
                       </a:r>
                     </a:p>
                   </a:txBody>
@@ -5378,13 +5527,13 @@
                     <a:lstStyle/>
                     <a:p>
                       <a:r>
-                        <a:rPr sz="1400" b="1">
+                        <a:rPr sz="1300" b="1">
                           <a:solidFill>
                             <a:srgbClr val="FFFFFF"/>
                           </a:solidFill>
                           <a:latin typeface="Calibri"/>
                         </a:rPr>
-                        <a:t>Tercapai</a:t>
+                        <a:t>Iterasi 2</a:t>
                       </a:r>
                     </a:p>
                   </a:txBody>
@@ -5395,14 +5544,14 @@
                   </a:tcPr>
                 </a:tc>
               </a:tr>
-              <a:tr h="429768">
-                <a:tc>
-                  <a:txBody>
-                    <a:bodyPr/>
-                    <a:lstStyle/>
-                    <a:p>
-                      <a:r>
-                        <a:rPr sz="1400" b="0">
+              <a:tr h="411480">
+                <a:tc>
+                  <a:txBody>
+                    <a:bodyPr/>
+                    <a:lstStyle/>
+                    <a:p>
+                      <a:r>
+                        <a:rPr sz="1300" b="0">
                           <a:solidFill>
                             <a:srgbClr val="222B38"/>
                           </a:solidFill>
@@ -5424,13 +5573,127 @@
                     <a:lstStyle/>
                     <a:p>
                       <a:r>
-                        <a:rPr sz="1400" b="0">
+                        <a:rPr sz="1300" b="0">
+                          <a:solidFill>
+                            <a:srgbClr val="D73027"/>
+                          </a:solidFill>
+                          <a:latin typeface="Calibri"/>
+                        </a:rPr>
+                        <a:t>0,543</a:t>
+                      </a:r>
+                    </a:p>
+                  </a:txBody>
+                  <a:tcPr anchor="ctr" marL="73152" marR="73152">
+                    <a:solidFill>
+                      <a:srgbClr val="FFFFFF"/>
+                    </a:solidFill>
+                  </a:tcPr>
+                </a:tc>
+                <a:tc>
+                  <a:txBody>
+                    <a:bodyPr/>
+                    <a:lstStyle/>
+                    <a:p>
+                      <a:r>
+                        <a:rPr sz="1300" b="0">
+                          <a:solidFill>
+                            <a:srgbClr val="1A9850"/>
+                          </a:solidFill>
+                          <a:latin typeface="Calibri"/>
+                        </a:rPr>
+                        <a:t>0,558</a:t>
+                      </a:r>
+                    </a:p>
+                  </a:txBody>
+                  <a:tcPr anchor="ctr" marL="73152" marR="73152">
+                    <a:solidFill>
+                      <a:srgbClr val="FFFFFF"/>
+                    </a:solidFill>
+                  </a:tcPr>
+                </a:tc>
+              </a:tr>
+              <a:tr h="411480">
+                <a:tc>
+                  <a:txBody>
+                    <a:bodyPr/>
+                    <a:lstStyle/>
+                    <a:p>
+                      <a:r>
+                        <a:rPr sz="1300" b="0">
                           <a:solidFill>
                             <a:srgbClr val="222B38"/>
                           </a:solidFill>
                           <a:latin typeface="Calibri"/>
                         </a:rPr>
-                        <a:t>0,558</a:t>
+                        <a:t>F1-macro ≥ 0,55</a:t>
+                      </a:r>
+                    </a:p>
+                  </a:txBody>
+                  <a:tcPr anchor="ctr" marL="73152" marR="73152">
+                    <a:solidFill>
+                      <a:srgbClr val="F3F5F9"/>
+                    </a:solidFill>
+                  </a:tcPr>
+                </a:tc>
+                <a:tc>
+                  <a:txBody>
+                    <a:bodyPr/>
+                    <a:lstStyle/>
+                    <a:p>
+                      <a:r>
+                        <a:rPr sz="1300" b="0">
+                          <a:solidFill>
+                            <a:srgbClr val="D73027"/>
+                          </a:solidFill>
+                          <a:latin typeface="Calibri"/>
+                        </a:rPr>
+                        <a:t>0,535</a:t>
+                      </a:r>
+                    </a:p>
+                  </a:txBody>
+                  <a:tcPr anchor="ctr" marL="73152" marR="73152">
+                    <a:solidFill>
+                      <a:srgbClr val="F3F5F9"/>
+                    </a:solidFill>
+                  </a:tcPr>
+                </a:tc>
+                <a:tc>
+                  <a:txBody>
+                    <a:bodyPr/>
+                    <a:lstStyle/>
+                    <a:p>
+                      <a:r>
+                        <a:rPr sz="1300" b="0">
+                          <a:solidFill>
+                            <a:srgbClr val="1A9850"/>
+                          </a:solidFill>
+                          <a:latin typeface="Calibri"/>
+                        </a:rPr>
+                        <a:t>0,554</a:t>
+                      </a:r>
+                    </a:p>
+                  </a:txBody>
+                  <a:tcPr anchor="ctr" marL="73152" marR="73152">
+                    <a:solidFill>
+                      <a:srgbClr val="F3F5F9"/>
+                    </a:solidFill>
+                  </a:tcPr>
+                </a:tc>
+              </a:tr>
+              <a:tr h="411480">
+                <a:tc>
+                  <a:txBody>
+                    <a:bodyPr/>
+                    <a:lstStyle/>
+                    <a:p>
+                      <a:r>
+                        <a:rPr sz="1300" b="0">
+                          <a:solidFill>
+                            <a:srgbClr val="222B38"/>
+                          </a:solidFill>
+                          <a:latin typeface="Calibri"/>
+                        </a:rPr>
+                        <a:t>ROC-AUC ≥ 0,58</a:t>
                       </a:r>
                     </a:p>
                   </a:txBody>
@@ -5446,13 +5709,35 @@
                     <a:lstStyle/>
                     <a:p>
                       <a:r>
-                        <a:rPr sz="1400" b="0">
+                        <a:rPr sz="1300" b="0">
+                          <a:solidFill>
+                            <a:srgbClr val="D73027"/>
+                          </a:solidFill>
+                          <a:latin typeface="Calibri"/>
+                        </a:rPr>
+                        <a:t>0,577</a:t>
+                      </a:r>
+                    </a:p>
+                  </a:txBody>
+                  <a:tcPr anchor="ctr" marL="73152" marR="73152">
+                    <a:solidFill>
+                      <a:srgbClr val="FFFFFF"/>
+                    </a:solidFill>
+                  </a:tcPr>
+                </a:tc>
+                <a:tc>
+                  <a:txBody>
+                    <a:bodyPr/>
+                    <a:lstStyle/>
+                    <a:p>
+                      <a:r>
+                        <a:rPr sz="1300" b="0">
                           <a:solidFill>
                             <a:srgbClr val="1A9850"/>
                           </a:solidFill>
                           <a:latin typeface="Calibri"/>
                         </a:rPr>
-                        <a:t>Ya</a:t>
+                        <a:t>0,583</a:t>
                       </a:r>
                     </a:p>
                   </a:txBody>
@@ -5463,20 +5748,20 @@
                   </a:tcPr>
                 </a:tc>
               </a:tr>
-              <a:tr h="429768">
-                <a:tc>
-                  <a:txBody>
-                    <a:bodyPr/>
-                    <a:lstStyle/>
-                    <a:p>
-                      <a:r>
-                        <a:rPr sz="1400" b="0">
+              <a:tr h="411480">
+                <a:tc>
+                  <a:txBody>
+                    <a:bodyPr/>
+                    <a:lstStyle/>
+                    <a:p>
+                      <a:r>
+                        <a:rPr sz="1300" b="0">
                           <a:solidFill>
                             <a:srgbClr val="222B38"/>
                           </a:solidFill>
                           <a:latin typeface="Calibri"/>
                         </a:rPr>
-                        <a:t>F1-macro ≥ 0,55</a:t>
+                        <a:t>Accuracy &gt; baseline "Selalu Naik"</a:t>
                       </a:r>
                     </a:p>
                   </a:txBody>
@@ -5492,13 +5777,13 @@
                     <a:lstStyle/>
                     <a:p>
                       <a:r>
-                        <a:rPr sz="1400" b="0">
-                          <a:solidFill>
-                            <a:srgbClr val="222B38"/>
-                          </a:solidFill>
-                          <a:latin typeface="Calibri"/>
-                        </a:rPr>
-                        <a:t>0,554</a:t>
+                        <a:rPr sz="1300" b="0">
+                          <a:solidFill>
+                            <a:srgbClr val="1A9850"/>
+                          </a:solidFill>
+                          <a:latin typeface="Calibri"/>
+                        </a:rPr>
+                        <a:t>+0,021</a:t>
                       </a:r>
                     </a:p>
                   </a:txBody>
@@ -5514,149 +5799,13 @@
                     <a:lstStyle/>
                     <a:p>
                       <a:r>
-                        <a:rPr sz="1400" b="0">
+                        <a:rPr sz="1300" b="0">
                           <a:solidFill>
                             <a:srgbClr val="1A9850"/>
                           </a:solidFill>
                           <a:latin typeface="Calibri"/>
                         </a:rPr>
-                        <a:t>Ya</a:t>
-                      </a:r>
-                    </a:p>
-                  </a:txBody>
-                  <a:tcPr anchor="ctr" marL="73152" marR="73152">
-                    <a:solidFill>
-                      <a:srgbClr val="F3F5F9"/>
-                    </a:solidFill>
-                  </a:tcPr>
-                </a:tc>
-              </a:tr>
-              <a:tr h="429768">
-                <a:tc>
-                  <a:txBody>
-                    <a:bodyPr/>
-                    <a:lstStyle/>
-                    <a:p>
-                      <a:r>
-                        <a:rPr sz="1400" b="0">
-                          <a:solidFill>
-                            <a:srgbClr val="222B38"/>
-                          </a:solidFill>
-                          <a:latin typeface="Calibri"/>
-                        </a:rPr>
-                        <a:t>ROC-AUC ≥ 0,58</a:t>
-                      </a:r>
-                    </a:p>
-                  </a:txBody>
-                  <a:tcPr anchor="ctr" marL="73152" marR="73152">
-                    <a:solidFill>
-                      <a:srgbClr val="FFFFFF"/>
-                    </a:solidFill>
-                  </a:tcPr>
-                </a:tc>
-                <a:tc>
-                  <a:txBody>
-                    <a:bodyPr/>
-                    <a:lstStyle/>
-                    <a:p>
-                      <a:r>
-                        <a:rPr sz="1400" b="0">
-                          <a:solidFill>
-                            <a:srgbClr val="222B38"/>
-                          </a:solidFill>
-                          <a:latin typeface="Calibri"/>
-                        </a:rPr>
-                        <a:t>0,583</a:t>
-                      </a:r>
-                    </a:p>
-                  </a:txBody>
-                  <a:tcPr anchor="ctr" marL="73152" marR="73152">
-                    <a:solidFill>
-                      <a:srgbClr val="FFFFFF"/>
-                    </a:solidFill>
-                  </a:tcPr>
-                </a:tc>
-                <a:tc>
-                  <a:txBody>
-                    <a:bodyPr/>
-                    <a:lstStyle/>
-                    <a:p>
-                      <a:r>
-                        <a:rPr sz="1400" b="0">
-                          <a:solidFill>
-                            <a:srgbClr val="1A9850"/>
-                          </a:solidFill>
-                          <a:latin typeface="Calibri"/>
-                        </a:rPr>
-                        <a:t>Ya</a:t>
-                      </a:r>
-                    </a:p>
-                  </a:txBody>
-                  <a:tcPr anchor="ctr" marL="73152" marR="73152">
-                    <a:solidFill>
-                      <a:srgbClr val="FFFFFF"/>
-                    </a:solidFill>
-                  </a:tcPr>
-                </a:tc>
-              </a:tr>
-              <a:tr h="429768">
-                <a:tc>
-                  <a:txBody>
-                    <a:bodyPr/>
-                    <a:lstStyle/>
-                    <a:p>
-                      <a:r>
-                        <a:rPr sz="1400" b="0">
-                          <a:solidFill>
-                            <a:srgbClr val="222B38"/>
-                          </a:solidFill>
-                          <a:latin typeface="Calibri"/>
-                        </a:rPr>
-                        <a:t>Accuracy &gt; baseline "Selalu Naik"</a:t>
-                      </a:r>
-                    </a:p>
-                  </a:txBody>
-                  <a:tcPr anchor="ctr" marL="73152" marR="73152">
-                    <a:solidFill>
-                      <a:srgbClr val="F3F5F9"/>
-                    </a:solidFill>
-                  </a:tcPr>
-                </a:tc>
-                <a:tc>
-                  <a:txBody>
-                    <a:bodyPr/>
-                    <a:lstStyle/>
-                    <a:p>
-                      <a:r>
-                        <a:rPr sz="1400" b="0">
-                          <a:solidFill>
-                            <a:srgbClr val="222B38"/>
-                          </a:solidFill>
-                          <a:latin typeface="Calibri"/>
-                        </a:rPr>
                         <a:t>+0,036</a:t>
-                      </a:r>
-                    </a:p>
-                  </a:txBody>
-                  <a:tcPr anchor="ctr" marL="73152" marR="73152">
-                    <a:solidFill>
-                      <a:srgbClr val="F3F5F9"/>
-                    </a:solidFill>
-                  </a:tcPr>
-                </a:tc>
-                <a:tc>
-                  <a:txBody>
-                    <a:bodyPr/>
-                    <a:lstStyle/>
-                    <a:p>
-                      <a:r>
-                        <a:rPr sz="1400" b="0">
-                          <a:solidFill>
-                            <a:srgbClr val="1A9850"/>
-                          </a:solidFill>
-                          <a:latin typeface="Calibri"/>
-                        </a:rPr>
-                        <a:t>Ya</a:t>
                       </a:r>
                     </a:p>
                   </a:txBody>
@@ -5671,9 +5820,48 @@
           </a:graphicData>
         </a:graphic>
       </p:graphicFrame>
+      <p:sp>
+        <p:nvSpPr>
+          <p:cNvPr id="11" name="TextBox 10"/>
+          <p:cNvSpPr txBox="1"/>
+          <p:nvPr/>
+        </p:nvSpPr>
+        <p:spPr>
+          <a:xfrm>
+            <a:off x="411480" y="5760720"/>
+            <a:ext cx="6400800" cy="365760"/>
+          </a:xfrm>
+          <a:prstGeom prst="rect">
+            <a:avLst/>
+          </a:prstGeom>
+          <a:noFill/>
+        </p:spPr>
+        <p:txBody>
+          <a:bodyPr wrap="square" anchor="t">
+            <a:spAutoFit/>
+          </a:bodyPr>
+          <a:lstStyle/>
+          <a:p>
+            <a:pPr algn="l">
+              <a:spcAft>
+                <a:spcPts val="800"/>
+              </a:spcAft>
+            </a:pPr>
+            <a:r>
+              <a:rPr sz="1100" b="0">
+                <a:solidFill>
+                  <a:srgbClr val="5A6778"/>
+                </a:solidFill>
+                <a:latin typeface="Calibri"/>
+              </a:rPr>
+              <a:t>Hijau = target tercapai, merah = belum.</a:t>
+            </a:r>
+          </a:p>
+        </p:txBody>
+      </p:sp>
       <p:pic>
         <p:nvPicPr>
-          <p:cNvPr id="11" name="Picture 10" descr="10_fitur_penting.png"/>
+          <p:cNvPr id="12" name="Picture 11" descr="10_fitur_penting.png"/>
           <p:cNvPicPr>
             <a:picLocks noChangeAspect="1"/>
           </p:cNvPicPr>
@@ -5697,7 +5885,7 @@
       </p:pic>
       <p:sp>
         <p:nvSpPr>
-          <p:cNvPr id="12" name="Rectangle 11"/>
+          <p:cNvPr id="13" name="Rectangle 12"/>
           <p:cNvSpPr/>
           <p:nvPr/>
         </p:nvSpPr>
@@ -5741,7 +5929,7 @@
       </p:sp>
       <p:sp>
         <p:nvSpPr>
-          <p:cNvPr id="13" name="Rectangle 12"/>
+          <p:cNvPr id="14" name="Rectangle 13"/>
           <p:cNvSpPr/>
           <p:nvPr/>
         </p:nvSpPr>
@@ -5785,7 +5973,7 @@
       </p:sp>
       <p:sp>
         <p:nvSpPr>
-          <p:cNvPr id="14" name="TextBox 13"/>
+          <p:cNvPr id="15" name="TextBox 14"/>
           <p:cNvSpPr txBox="1"/>
           <p:nvPr/>
         </p:nvSpPr>
@@ -5849,7 +6037,7 @@
                 </a:solidFill>
                 <a:latin typeface="Calibri"/>
               </a:rPr>
-              <a:t>•  4 dari 4 target tercapai, tetapi tipis</a:t>
+              <a:t>•  Iterasi 2: 4 dari 4 target, tetapi tipis</a:t>
             </a:r>
           </a:p>
           <a:p>
@@ -5865,7 +6053,7 @@
                 </a:solidFill>
                 <a:latin typeface="Calibri"/>
               </a:rPr>
-              <a:t>•  Iterasi ke-2: 1 variabel lemah dibuang</a:t>
+              <a:t>•  Iterasi 1 (dengan kurs): 1 dari 4 target</a:t>
             </a:r>
           </a:p>
           <a:p>
@@ -7429,7 +7617,7 @@
                 </a:solidFill>
                 <a:latin typeface="Calibri"/>
               </a:rPr>
-              <a:t>IHSG dipengaruhi pasar global: saham Amerika, indeks ketakutan (VIX), harga minyak, dan emas.</a:t>
+              <a:t>IHSG dipengaruhi pasar global dan kurs: saham Amerika, indeks ketakutan (VIX), harga minyak, emas, dan kurs rupiah.</a:t>
             </a:r>
           </a:p>
           <a:p>
@@ -8063,7 +8251,7 @@
         </p:nvGraphicFramePr>
         <p:xfrm>
           <a:off x="7635240" y="1234440"/>
-          <a:ext cx="4160520" cy="1920240"/>
+          <a:ext cx="4160520" cy="2304288"/>
         </p:xfrm>
         <a:graphic>
           <a:graphicData uri="http://schemas.openxmlformats.org/drawingml/2006/table">
@@ -8305,6 +8493,52 @@
                   </a:tcPr>
                 </a:tc>
               </a:tr>
+              <a:tr h="384048">
+                <a:tc>
+                  <a:txBody>
+                    <a:bodyPr/>
+                    <a:lstStyle/>
+                    <a:p>
+                      <a:r>
+                        <a:rPr sz="1300" b="0">
+                          <a:solidFill>
+                            <a:srgbClr val="222B38"/>
+                          </a:solidFill>
+                          <a:latin typeface="Calibri"/>
+                        </a:rPr>
+                        <a:t>USDIDR</a:t>
+                      </a:r>
+                    </a:p>
+                  </a:txBody>
+                  <a:tcPr anchor="ctr" marL="73152" marR="73152">
+                    <a:solidFill>
+                      <a:srgbClr val="FFFFFF"/>
+                    </a:solidFill>
+                  </a:tcPr>
+                </a:tc>
+                <a:tc>
+                  <a:txBody>
+                    <a:bodyPr/>
+                    <a:lstStyle/>
+                    <a:p>
+                      <a:r>
+                        <a:rPr sz="1300" b="0">
+                          <a:solidFill>
+                            <a:srgbClr val="222B38"/>
+                          </a:solidFill>
+                          <a:latin typeface="Calibri"/>
+                        </a:rPr>
+                        <a:t>Kurs rupiah per dolar AS</a:t>
+                      </a:r>
+                    </a:p>
+                  </a:txBody>
+                  <a:tcPr anchor="ctr" marL="73152" marR="73152">
+                    <a:solidFill>
+                      <a:srgbClr val="FFFFFF"/>
+                    </a:solidFill>
+                  </a:tcPr>
+                </a:tc>
+              </a:tr>
             </a:tbl>
           </a:graphicData>
         </a:graphic>
@@ -8447,7 +8681,7 @@
                 </a:solidFill>
                 <a:latin typeface="Calibri"/>
               </a:rPr>
-              <a:t>Data nyata harian 1 Jan 2010 – 30 Sep 2026 dari Yahoo Finance: 4.365 baris hari kerja, 5 variabel. IHSG naik pada 54% hari bursa.</a:t>
+              <a:t>Data nyata harian 1 Jan 2010 – 30 Sep 2026 dari Yahoo Finance: 4.365 baris hari kerja, 6 variabel. IHSG naik pada 54% hari bursa.</a:t>
             </a:r>
           </a:p>
         </p:txBody>
@@ -8685,7 +8919,7 @@
         </p:nvGraphicFramePr>
         <p:xfrm>
           <a:off x="411480" y="1188720"/>
-          <a:ext cx="11384280" cy="3401568"/>
+          <a:ext cx="11384280" cy="3520440"/>
         </p:xfrm>
         <a:graphic>
           <a:graphicData uri="http://schemas.openxmlformats.org/drawingml/2006/table">
@@ -8699,7 +8933,7 @@
                 <a:gridCol w="2514600"/>
                 <a:gridCol w="3474720"/>
               </a:tblGrid>
-              <a:tr h="566928">
+              <a:tr h="502920">
                 <a:tc>
                   <a:txBody>
                     <a:bodyPr/>
@@ -8789,7 +9023,7 @@
                   </a:tcPr>
                 </a:tc>
               </a:tr>
-              <a:tr h="566928">
+              <a:tr h="502920">
                 <a:tc>
                   <a:txBody>
                     <a:bodyPr/>
@@ -8879,7 +9113,7 @@
                   </a:tcPr>
                 </a:tc>
               </a:tr>
-              <a:tr h="566928">
+              <a:tr h="502920">
                 <a:tc>
                   <a:txBody>
                     <a:bodyPr/>
@@ -8969,7 +9203,7 @@
                   </a:tcPr>
                 </a:tc>
               </a:tr>
-              <a:tr h="566928">
+              <a:tr h="502920">
                 <a:tc>
                   <a:txBody>
                     <a:bodyPr/>
@@ -9059,7 +9293,7 @@
                   </a:tcPr>
                 </a:tc>
               </a:tr>
-              <a:tr h="566928">
+              <a:tr h="502920">
                 <a:tc>
                   <a:txBody>
                     <a:bodyPr/>
@@ -9149,7 +9383,7 @@
                   </a:tcPr>
                 </a:tc>
               </a:tr>
-              <a:tr h="566928">
+              <a:tr h="502920">
                 <a:tc>
                   <a:txBody>
                     <a:bodyPr/>
@@ -9235,6 +9469,96 @@
                   <a:tcPr anchor="ctr" marL="73152" marR="73152">
                     <a:solidFill>
                       <a:srgbClr val="FFFFFF"/>
+                    </a:solidFill>
+                  </a:tcPr>
+                </a:tc>
+              </a:tr>
+              <a:tr h="502920">
+                <a:tc>
+                  <a:txBody>
+                    <a:bodyPr/>
+                    <a:lstStyle/>
+                    <a:p>
+                      <a:r>
+                        <a:rPr sz="1300" b="0">
+                          <a:solidFill>
+                            <a:srgbClr val="222B38"/>
+                          </a:solidFill>
+                          <a:latin typeface="Calibri"/>
+                        </a:rPr>
+                        <a:t>Kurs (USD/IDR)</a:t>
+                      </a:r>
+                    </a:p>
+                  </a:txBody>
+                  <a:tcPr anchor="ctr" marL="73152" marR="73152">
+                    <a:solidFill>
+                      <a:srgbClr val="F3F5F9"/>
+                    </a:solidFill>
+                  </a:tcPr>
+                </a:tc>
+                <a:tc>
+                  <a:txBody>
+                    <a:bodyPr/>
+                    <a:lstStyle/>
+                    <a:p>
+                      <a:r>
+                        <a:rPr sz="1300" b="0">
+                          <a:solidFill>
+                            <a:srgbClr val="222B38"/>
+                          </a:solidFill>
+                          <a:latin typeface="Calibri"/>
+                        </a:rPr>
+                        <a:t>Banyaknya rupiah untuk membeli 1 dolar AS</a:t>
+                      </a:r>
+                    </a:p>
+                  </a:txBody>
+                  <a:tcPr anchor="ctr" marL="73152" marR="73152">
+                    <a:solidFill>
+                      <a:srgbClr val="F3F5F9"/>
+                    </a:solidFill>
+                  </a:tcPr>
+                </a:tc>
+                <a:tc>
+                  <a:txBody>
+                    <a:bodyPr/>
+                    <a:lstStyle/>
+                    <a:p>
+                      <a:r>
+                        <a:rPr sz="1300" b="0">
+                          <a:solidFill>
+                            <a:srgbClr val="222B38"/>
+                          </a:solidFill>
+                          <a:latin typeface="Calibri"/>
+                        </a:rPr>
+                        <a:t>rupiah per USD; naik = rupiah melemah</a:t>
+                      </a:r>
+                    </a:p>
+                  </a:txBody>
+                  <a:tcPr anchor="ctr" marL="73152" marR="73152">
+                    <a:solidFill>
+                      <a:srgbClr val="F3F5F9"/>
+                    </a:solidFill>
+                  </a:tcPr>
+                </a:tc>
+                <a:tc>
+                  <a:txBody>
+                    <a:bodyPr/>
+                    <a:lstStyle/>
+                    <a:p>
+                      <a:r>
+                        <a:rPr sz="1300" b="0">
+                          <a:solidFill>
+                            <a:srgbClr val="222B38"/>
+                          </a:solidFill>
+                          <a:latin typeface="Calibri"/>
+                        </a:rPr>
+                        <a:t>Rupiah melemah ↔ investor asing menjual</a:t>
+                      </a:r>
+                    </a:p>
+                  </a:txBody>
+                  <a:tcPr anchor="ctr" marL="73152" marR="73152">
+                    <a:solidFill>
+                      <a:srgbClr val="F3F5F9"/>
                     </a:solidFill>
                   </a:tcPr>
                 </a:tc>
@@ -9251,7 +9575,7 @@
         </p:nvSpPr>
         <p:spPr>
           <a:xfrm>
-            <a:off x="411480" y="4800600"/>
+            <a:off x="411480" y="4846320"/>
             <a:ext cx="11384280" cy="1280160"/>
           </a:xfrm>
           <a:prstGeom prst="rect">
@@ -9295,7 +9619,7 @@
         </p:nvSpPr>
         <p:spPr>
           <a:xfrm>
-            <a:off x="411480" y="4800600"/>
+            <a:off x="411480" y="4846320"/>
             <a:ext cx="64008" cy="1280160"/>
           </a:xfrm>
           <a:prstGeom prst="rect">
@@ -9339,7 +9663,7 @@
         </p:nvSpPr>
         <p:spPr>
           <a:xfrm>
-            <a:off x="640080" y="4910328"/>
+            <a:off x="640080" y="4956048"/>
             <a:ext cx="11018519" cy="1097280"/>
           </a:xfrm>
           <a:prstGeom prst="rect">
@@ -9381,7 +9705,7 @@
                 </a:solidFill>
                 <a:latin typeface="Calibri"/>
               </a:rPr>
-              <a:t>BEI ±09.00–16.00 · Bursa AS ±20.30–03.00 (Maret–November) atau ±21.30–04.00 (November–Maret). Sumber data: Yahoo Finance (^JKSE, ^GSPC, ^VIX, CL=F, GC=F).</a:t>
+              <a:t>BEI ±09.00–16.00 · Bursa AS ±20.30–03.00 (Maret–November) atau ±21.30–04.00 (November–Maret) · Kurs harian ditutup ±06.00–07.00. Sumber: Yahoo Finance (^JKSE, ^GSPC, ^VIX, CL=F, GC=F, IDR=X).</a:t>
             </a:r>
           </a:p>
         </p:txBody>
@@ -9961,7 +10285,7 @@
                           </a:solidFill>
                           <a:latin typeface="Calibri"/>
                         </a:rPr>
-                        <a:t>Menemukan 3 jenis masalah data</a:t>
+                        <a:t>Menemukan 4 jenis masalah data</a:t>
                       </a:r>
                     </a:p>
                   </a:txBody>
@@ -10029,7 +10353,7 @@
                           </a:solidFill>
                           <a:latin typeface="Calibri"/>
                         </a:rPr>
-                        <a:t>Memilih 5 variabel dan target</a:t>
+                        <a:t>Memilih 6 variabel dan target</a:t>
                       </a:r>
                     </a:p>
                   </a:txBody>
@@ -10097,7 +10421,7 @@
                           </a:solidFill>
                           <a:latin typeface="Calibri"/>
                         </a:rPr>
-                        <a:t>3 langkah perbaikan</a:t>
+                        <a:t>4 langkah perbaikan</a:t>
                       </a:r>
                     </a:p>
                   </a:txBody>
@@ -10165,7 +10489,7 @@
                           </a:solidFill>
                           <a:latin typeface="Calibri"/>
                         </a:rPr>
-                        <a:t>5 fitur, data latih 80% &amp; uji 20%</a:t>
+                        <a:t>6 fitur, data latih 80% &amp; uji 20%</a:t>
                       </a:r>
                     </a:p>
                   </a:txBody>
@@ -10233,7 +10557,7 @@
                           </a:solidFill>
                           <a:latin typeface="Calibri"/>
                         </a:rPr>
-                        <a:t>2 baseline + 3 model</a:t>
+                        <a:t>2 baseline + 3 model, 2 iterasi fitur</a:t>
                       </a:r>
                     </a:p>
                   </a:txBody>
@@ -10369,7 +10693,7 @@
                           </a:solidFill>
                           <a:latin typeface="Calibri"/>
                         </a:rPr>
-                        <a:t>Uji dengan data baru</a:t>
+                        <a:t>Uji kedua iterasi dengan data uji</a:t>
                       </a:r>
                     </a:p>
                   </a:txBody>
@@ -11709,8 +12033,8 @@
         </p:blipFill>
         <p:spPr>
           <a:xfrm>
-            <a:off x="411480" y="1202611"/>
-            <a:ext cx="6766560" cy="3812696"/>
+            <a:off x="411480" y="1229716"/>
+            <a:ext cx="6766560" cy="3758487"/>
           </a:xfrm>
           <a:prstGeom prst="rect">
             <a:avLst/>
@@ -11804,6 +12128,40 @@
                 <a:latin typeface="Calibri"/>
               </a:rPr>
               <a:t>berhubungan terbalik (−0,24): saat pasar takut, IHSG cenderung turun.</a:t>
+            </a:r>
+          </a:p>
+          <a:p>
+            <a:pPr algn="l">
+              <a:spcAft>
+                <a:spcPts val="800"/>
+              </a:spcAft>
+            </a:pPr>
+            <a:r>
+              <a:rPr sz="1000" b="0">
+                <a:solidFill>
+                  <a:srgbClr val="E08214"/>
+                </a:solidFill>
+                <a:latin typeface="Calibri"/>
+              </a:rPr>
+              <a:t>■  </a:t>
+            </a:r>
+            <a:r>
+              <a:rPr sz="1600" b="1">
+                <a:solidFill>
+                  <a:srgbClr val="222B38"/>
+                </a:solidFill>
+                <a:latin typeface="Calibri"/>
+              </a:rPr>
+              <a:t>Kurs USD/IDR </a:t>
+            </a:r>
+            <a:r>
+              <a:rPr sz="1600" b="0">
+                <a:solidFill>
+                  <a:srgbClr val="222B38"/>
+                </a:solidFill>
+                <a:latin typeface="Calibri"/>
+              </a:rPr>
+              <a:t>hampir tidak berhubungan (−0,02).</a:t>
             </a:r>
           </a:p>
           <a:p>
@@ -12155,25 +12513,49 @@
         </p:blipFill>
         <p:spPr>
           <a:xfrm>
-            <a:off x="2579820" y="1188720"/>
-            <a:ext cx="7047598" cy="2651760"/>
+            <a:off x="411480" y="1328068"/>
+            <a:ext cx="5577840" cy="2098742"/>
           </a:xfrm>
           <a:prstGeom prst="rect">
             <a:avLst/>
           </a:prstGeom>
         </p:spPr>
       </p:pic>
+      <p:pic>
+        <p:nvPicPr>
+          <p:cNvPr id="10" name="Picture 9" descr="04_kurs_janggal.png"/>
+          <p:cNvPicPr>
+            <a:picLocks noChangeAspect="1"/>
+          </p:cNvPicPr>
+          <p:nvPr/>
+        </p:nvPicPr>
+        <p:blipFill>
+          <a:blip r:embed="rId3"/>
+          <a:stretch>
+            <a:fillRect/>
+          </a:stretch>
+        </p:blipFill>
+        <p:spPr>
+          <a:xfrm>
+            <a:off x="6217920" y="1343408"/>
+            <a:ext cx="5577840" cy="2068062"/>
+          </a:xfrm>
+          <a:prstGeom prst="rect">
+            <a:avLst/>
+          </a:prstGeom>
+        </p:spPr>
+      </p:pic>
       <p:graphicFrame>
         <p:nvGraphicFramePr>
-          <p:cNvPr id="10" name="Table 9"/>
+          <p:cNvPr id="11" name="Table 10"/>
           <p:cNvGraphicFramePr>
             <a:graphicFrameLocks noGrp="1"/>
           </p:cNvGraphicFramePr>
           <p:nvPr/>
         </p:nvGraphicFramePr>
         <p:xfrm>
-          <a:off x="411480" y="3977639"/>
-          <a:ext cx="11384280" cy="1920240"/>
+          <a:off x="411480" y="3749039"/>
+          <a:ext cx="11384280" cy="2304288"/>
         </p:xfrm>
         <a:graphic>
           <a:graphicData uri="http://schemas.openxmlformats.org/drawingml/2006/table">
@@ -12471,13 +12853,81 @@
                           </a:solidFill>
                           <a:latin typeface="Calibri"/>
                         </a:rPr>
+                        <a:t>Kurs USD/IDR janggal (mis. 888 pada 1 Nov 2010)</a:t>
+                      </a:r>
+                    </a:p>
+                  </a:txBody>
+                  <a:tcPr anchor="ctr" marL="73152" marR="73152">
+                    <a:solidFill>
+                      <a:srgbClr val="F3F5F9"/>
+                    </a:solidFill>
+                  </a:tcPr>
+                </a:tc>
+                <a:tc>
+                  <a:txBody>
+                    <a:bodyPr/>
+                    <a:lstStyle/>
+                    <a:p>
+                      <a:r>
+                        <a:rPr sz="1300" b="0">
+                          <a:solidFill>
+                            <a:srgbClr val="222B38"/>
+                          </a:solidFill>
+                          <a:latin typeface="Calibri"/>
+                        </a:rPr>
+                        <a:t>15 nilai</a:t>
+                      </a:r>
+                    </a:p>
+                  </a:txBody>
+                  <a:tcPr anchor="ctr" marL="73152" marR="73152">
+                    <a:solidFill>
+                      <a:srgbClr val="F3F5F9"/>
+                    </a:solidFill>
+                  </a:tcPr>
+                </a:tc>
+                <a:tc>
+                  <a:txBody>
+                    <a:bodyPr/>
+                    <a:lstStyle/>
+                    <a:p>
+                      <a:r>
+                        <a:rPr sz="1300" b="0">
+                          <a:solidFill>
+                            <a:srgbClr val="222B38"/>
+                          </a:solidFill>
+                          <a:latin typeface="Calibri"/>
+                        </a:rPr>
+                        <a:t>Diganti nilai hari sebelumnya</a:t>
+                      </a:r>
+                    </a:p>
+                  </a:txBody>
+                  <a:tcPr anchor="ctr" marL="73152" marR="73152">
+                    <a:solidFill>
+                      <a:srgbClr val="F3F5F9"/>
+                    </a:solidFill>
+                  </a:tcPr>
+                </a:tc>
+              </a:tr>
+              <a:tr h="384048">
+                <a:tc>
+                  <a:txBody>
+                    <a:bodyPr/>
+                    <a:lstStyle/>
+                    <a:p>
+                      <a:r>
+                        <a:rPr sz="1300" b="0">
+                          <a:solidFill>
+                            <a:srgbClr val="222B38"/>
+                          </a:solidFill>
+                          <a:latin typeface="Calibri"/>
+                        </a:rPr>
                         <a:t>Hari libur BEI (IHSG disalin)</a:t>
                       </a:r>
                     </a:p>
                   </a:txBody>
                   <a:tcPr anchor="ctr" marL="73152" marR="73152">
                     <a:solidFill>
-                      <a:srgbClr val="F3F5F9"/>
+                      <a:srgbClr val="FFFFFF"/>
                     </a:solidFill>
                   </a:tcPr>
                 </a:tc>
@@ -12499,7 +12949,7 @@
                   </a:txBody>
                   <a:tcPr anchor="ctr" marL="73152" marR="73152">
                     <a:solidFill>
-                      <a:srgbClr val="F3F5F9"/>
+                      <a:srgbClr val="FFFFFF"/>
                     </a:solidFill>
                   </a:tcPr>
                 </a:tc>
@@ -12521,7 +12971,7 @@
                   </a:txBody>
                   <a:tcPr anchor="ctr" marL="73152" marR="73152">
                     <a:solidFill>
-                      <a:srgbClr val="F3F5F9"/>
+                      <a:srgbClr val="FFFFFF"/>
                     </a:solidFill>
                   </a:tcPr>
                 </a:tc>
@@ -12846,7 +13296,7 @@
         </p:nvGraphicFramePr>
         <p:xfrm>
           <a:off x="411480" y="1234440"/>
-          <a:ext cx="5577840" cy="1828800"/>
+          <a:ext cx="5577840" cy="2286000"/>
         </p:xfrm>
         <a:graphic>
           <a:graphicData uri="http://schemas.openxmlformats.org/drawingml/2006/table">
@@ -12855,8 +13305,8 @@
                 <a:tableStyleId>{5C22544A-7EE6-4342-B048-85BDC9FD1C3A}</a:tableStyleId>
               </a:tblPr>
               <a:tblGrid>
-                <a:gridCol w="2651760"/>
-                <a:gridCol w="2926080"/>
+                <a:gridCol w="2194560"/>
+                <a:gridCol w="3383280"/>
               </a:tblGrid>
               <a:tr h="457200">
                 <a:tc>
@@ -13009,13 +13459,59 @@
                           </a:solidFill>
                           <a:latin typeface="Calibri"/>
                         </a:rPr>
+                        <a:t>USDIDR</a:t>
+                      </a:r>
+                    </a:p>
+                  </a:txBody>
+                  <a:tcPr anchor="ctr" marL="73152" marR="73152">
+                    <a:solidFill>
+                      <a:srgbClr val="FFFFFF"/>
+                    </a:solidFill>
+                  </a:tcPr>
+                </a:tc>
+                <a:tc>
+                  <a:txBody>
+                    <a:bodyPr/>
+                    <a:lstStyle/>
+                    <a:p>
+                      <a:r>
+                        <a:rPr sz="1400" b="0">
+                          <a:solidFill>
+                            <a:srgbClr val="E08214"/>
+                          </a:solidFill>
+                          <a:latin typeface="Calibri"/>
+                        </a:rPr>
+                        <a:t>Ya, iterasi 1 (dikeluarkan di iterasi 2)</a:t>
+                      </a:r>
+                    </a:p>
+                  </a:txBody>
+                  <a:tcPr anchor="ctr" marL="73152" marR="73152">
+                    <a:solidFill>
+                      <a:srgbClr val="FFFFFF"/>
+                    </a:solidFill>
+                  </a:tcPr>
+                </a:tc>
+              </a:tr>
+              <a:tr h="457200">
+                <a:tc>
+                  <a:txBody>
+                    <a:bodyPr/>
+                    <a:lstStyle/>
+                    <a:p>
+                      <a:r>
+                        <a:rPr sz="1400" b="0">
+                          <a:solidFill>
+                            <a:srgbClr val="222B38"/>
+                          </a:solidFill>
+                          <a:latin typeface="Calibri"/>
+                        </a:rPr>
                         <a:t>CPI, BI_rate, US_rate</a:t>
                       </a:r>
                     </a:p>
                   </a:txBody>
                   <a:tcPr anchor="ctr" marL="73152" marR="73152">
                     <a:solidFill>
-                      <a:srgbClr val="FFFFFF"/>
+                      <a:srgbClr val="F3F5F9"/>
                     </a:solidFill>
                   </a:tcPr>
                 </a:tc>
@@ -13037,7 +13533,7 @@
                   </a:txBody>
                   <a:tcPr anchor="ctr" marL="73152" marR="73152">
                     <a:solidFill>
-                      <a:srgbClr val="FFFFFF"/>
+                      <a:srgbClr val="F3F5F9"/>
                     </a:solidFill>
                   </a:tcPr>
                 </a:tc>
@@ -13054,7 +13550,7 @@
         </p:nvSpPr>
         <p:spPr>
           <a:xfrm>
-            <a:off x="411480" y="3749039"/>
+            <a:off x="411480" y="3886200"/>
             <a:ext cx="5577840" cy="1463040"/>
           </a:xfrm>
           <a:prstGeom prst="rect">
@@ -13129,7 +13625,7 @@
         </p:nvGraphicFramePr>
         <p:xfrm>
           <a:off x="6263640" y="1234440"/>
-          <a:ext cx="5532120" cy="1828800"/>
+          <a:ext cx="5532120" cy="2286000"/>
         </p:xfrm>
         <a:graphic>
           <a:graphicData uri="http://schemas.openxmlformats.org/drawingml/2006/table">
@@ -13246,7 +13742,7 @@
                           </a:solidFill>
                           <a:latin typeface="Calibri"/>
                         </a:rPr>
-                        <a:t>2. Perbaiki minyak negatif</a:t>
+                        <a:t>2. Perbaiki kurs janggal</a:t>
                       </a:r>
                     </a:p>
                   </a:txBody>
@@ -13268,7 +13764,7 @@
                           </a:solidFill>
                           <a:latin typeface="Calibri"/>
                         </a:rPr>
-                        <a:t>1 nilai</a:t>
+                        <a:t>15 nilai</a:t>
                       </a:r>
                     </a:p>
                   </a:txBody>
@@ -13292,7 +13788,7 @@
                           </a:solidFill>
                           <a:latin typeface="Calibri"/>
                         </a:rPr>
-                        <a:t>3. Hapus hari libur BEI</a:t>
+                        <a:t>3. Perbaiki minyak negatif</a:t>
                       </a:r>
                     </a:p>
                   </a:txBody>
@@ -13314,13 +13810,59 @@
                           </a:solidFill>
                           <a:latin typeface="Calibri"/>
                         </a:rPr>
+                        <a:t>1 nilai</a:t>
+                      </a:r>
+                    </a:p>
+                  </a:txBody>
+                  <a:tcPr anchor="ctr" marL="73152" marR="73152">
+                    <a:solidFill>
+                      <a:srgbClr val="FFFFFF"/>
+                    </a:solidFill>
+                  </a:tcPr>
+                </a:tc>
+              </a:tr>
+              <a:tr h="457200">
+                <a:tc>
+                  <a:txBody>
+                    <a:bodyPr/>
+                    <a:lstStyle/>
+                    <a:p>
+                      <a:r>
+                        <a:rPr sz="1400" b="0">
+                          <a:solidFill>
+                            <a:srgbClr val="222B38"/>
+                          </a:solidFill>
+                          <a:latin typeface="Calibri"/>
+                        </a:rPr>
+                        <a:t>4. Hapus hari libur BEI</a:t>
+                      </a:r>
+                    </a:p>
+                  </a:txBody>
+                  <a:tcPr anchor="ctr" marL="73152" marR="73152">
+                    <a:solidFill>
+                      <a:srgbClr val="F3F5F9"/>
+                    </a:solidFill>
+                  </a:tcPr>
+                </a:tc>
+                <a:tc>
+                  <a:txBody>
+                    <a:bodyPr/>
+                    <a:lstStyle/>
+                    <a:p>
+                      <a:r>
+                        <a:rPr sz="1400" b="0">
+                          <a:solidFill>
+                            <a:srgbClr val="222B38"/>
+                          </a:solidFill>
+                          <a:latin typeface="Calibri"/>
+                        </a:rPr>
                         <a:t>4.364 → 4.060</a:t>
                       </a:r>
                     </a:p>
                   </a:txBody>
                   <a:tcPr anchor="ctr" marL="73152" marR="73152">
                     <a:solidFill>
-                      <a:srgbClr val="FFFFFF"/>
+                      <a:srgbClr val="F3F5F9"/>
                     </a:solidFill>
                   </a:tcPr>
                 </a:tc>
@@ -13337,7 +13879,7 @@
         </p:nvSpPr>
         <p:spPr>
           <a:xfrm>
-            <a:off x="6263640" y="3291840"/>
+            <a:off x="6263640" y="3749039"/>
             <a:ext cx="5532120" cy="1097280"/>
           </a:xfrm>
           <a:prstGeom prst="rect">
@@ -13381,7 +13923,7 @@
         </p:nvSpPr>
         <p:spPr>
           <a:xfrm>
-            <a:off x="6263640" y="3291840"/>
+            <a:off x="6263640" y="3749039"/>
             <a:ext cx="64008" cy="1097280"/>
           </a:xfrm>
           <a:prstGeom prst="rect">
@@ -13425,7 +13967,7 @@
         </p:nvSpPr>
         <p:spPr>
           <a:xfrm>
-            <a:off x="6492240" y="3401568"/>
+            <a:off x="6492240" y="3858768"/>
             <a:ext cx="5166359" cy="914400"/>
           </a:xfrm>
           <a:prstGeom prst="rect">

</xml_diff>